<commit_message>
Trim pitch deck to short labels; detail stays in speaker notes
Co-Authored-By: Claude Opus 5.5 <noreply@anthropic.com>
</commit_message>
<xml_diff>
--- a/hirebuddy-pitch.pptx
+++ b/hirebuddy-pitch.pptx
@@ -113,24 +113,24 @@
   <p:extLst>
     <p:ext uri="{521415D9-36F7-43E2-AB2F-B90AF26B5E84}">
       <p14:sectionLst xmlns:p14="http://schemas.microsoft.com/office/powerpoint/2010/main">
-        <p14:section name="Problem" id="{580d89d0-86c1-3ea6-25e0-aa1c7bb76afc}">
+        <p14:section name="Problem" id="{ab1cd84f-84d0-fcc4-df39-1af7d8c46d40}">
           <p14:sldIdLst>
             <p14:sldId id="256"/>
           </p14:sldIdLst>
         </p14:section>
-        <p14:section name="Solution" id="{ada76e4e-8c26-98b2-3622-d688e048a0a1}">
+        <p14:section name="Solution" id="{d377a365-bd39-07ec-eb43-a4c84769dab2}">
           <p14:sldIdLst>
             <p14:sldId id="257"/>
             <p14:sldId id="258"/>
           </p14:sldIdLst>
         </p14:section>
-        <p14:section name="How it works" id="{973454a4-531a-f018-4c8f-23aa4265856c}">
+        <p14:section name="How it works" id="{177309f3-cc36-6a8b-f5b6-bda89b43a69f}">
           <p14:sldIdLst>
             <p14:sldId id="259"/>
             <p14:sldId id="260"/>
           </p14:sldIdLst>
         </p14:section>
-        <p14:section name="Close" id="{a81978e1-daed-4303-d55d-fb57af45455d}">
+        <p14:section name="Close" id="{54755c53-a337-b894-a485-ae68158c5d69}">
           <p14:sldIdLst>
             <p14:sldId id="261"/>
             <p14:sldId id="262"/>
@@ -1917,8 +1917,8 @@
         </p:nvSpPr>
         <p:spPr>
           <a:xfrm>
-            <a:off x="548640" y="3886200"/>
-            <a:ext cx="8686800" cy="914400"/>
+            <a:off x="548640" y="3931920"/>
+            <a:ext cx="10058400" cy="457200"/>
           </a:xfrm>
           <a:prstGeom prst="rect">
             <a:avLst/>
@@ -1927,144 +1927,21 @@
           <a:ln/>
         </p:spPr>
         <p:txBody>
-          <a:bodyPr wrap="square" lIns="0" tIns="0" rIns="0" bIns="0" rtlCol="0" anchor="t"/>
+          <a:bodyPr wrap="square" lIns="0" tIns="0" rIns="0" bIns="0" rtlCol="0" anchor="ctr"/>
           <a:lstStyle/>
           <a:p>
             <a:pPr indent="0" marL="0">
-              <a:lnSpc>
-                <a:spcPct val="130000"/>
-              </a:lnSpc>
-              <a:buNone/>
-            </a:pPr>
-            <a:r>
-              <a:rPr lang="en-US" sz="1600" dirty="0">
+              <a:buNone/>
+            </a:pPr>
+            <a:r>
+              <a:rPr lang="en-US" sz="2000" dirty="0">
                 <a:solidFill>
                   <a:schemeClr val="bg2"/>
                 </a:solidFill>
               </a:rPr>
-              <a:t>In Malaysia, blind and low-vision job seekers struggle to find work because job search platforms are hard to use with a screen reader, and checking every listing for pay, hours, travel and sight requirements takes hours.</a:t>
-            </a:r>
-            <a:endParaRPr lang="en-US" sz="1600" dirty="0"/>
-          </a:p>
-        </p:txBody>
-      </p:sp>
-      <p:sp>
-        <p:nvSpPr>
-          <p:cNvPr id="5" name="Chip 1"/>
-          <p:cNvSpPr txBox="1"/>
-          <p:nvPr/>
-        </p:nvSpPr>
-        <p:spPr>
-          <a:xfrm>
-            <a:off x="548640" y="5120640"/>
-            <a:ext cx="2514600" cy="457200"/>
-          </a:xfrm>
-          <a:prstGeom prst="roundRect">
-            <a:avLst>
-              <a:gd name="adj" fmla="val 16000"/>
-            </a:avLst>
-          </a:prstGeom>
-          <a:solidFill>
-            <a:srgbClr val="1E293B"/>
-          </a:solidFill>
-          <a:ln/>
-        </p:spPr>
-        <p:txBody>
-          <a:bodyPr wrap="square" lIns="50800" tIns="50800" rIns="50800" bIns="50800" rtlCol="0" anchor="ctr"/>
-          <a:lstStyle/>
-          <a:p>
-            <a:pPr algn="ctr" indent="0" marL="0">
-              <a:buNone/>
-            </a:pPr>
-            <a:r>
-              <a:rPr lang="en-US" sz="1300" b="1" dirty="0">
-                <a:solidFill>
-                  <a:schemeClr val="accent2"/>
-                </a:solidFill>
-              </a:rPr>
-              <a:t>Runs inside WorkBuddy</a:t>
-            </a:r>
-            <a:endParaRPr lang="en-US" sz="1300" dirty="0"/>
-          </a:p>
-        </p:txBody>
-      </p:sp>
-      <p:sp>
-        <p:nvSpPr>
-          <p:cNvPr id="6" name="Chip 2"/>
-          <p:cNvSpPr txBox="1"/>
-          <p:nvPr/>
-        </p:nvSpPr>
-        <p:spPr>
-          <a:xfrm>
-            <a:off x="3246120" y="5120640"/>
-            <a:ext cx="2514600" cy="457200"/>
-          </a:xfrm>
-          <a:prstGeom prst="roundRect">
-            <a:avLst>
-              <a:gd name="adj" fmla="val 16000"/>
-            </a:avLst>
-          </a:prstGeom>
-          <a:solidFill>
-            <a:srgbClr val="1E293B"/>
-          </a:solidFill>
-          <a:ln/>
-        </p:spPr>
-        <p:txBody>
-          <a:bodyPr wrap="square" lIns="50800" tIns="50800" rIns="50800" bIns="50800" rtlCol="0" anchor="ctr"/>
-          <a:lstStyle/>
-          <a:p>
-            <a:pPr algn="ctr" indent="0" marL="0">
-              <a:buNone/>
-            </a:pPr>
-            <a:r>
-              <a:rPr lang="en-US" sz="1300" b="1" dirty="0">
-                <a:solidFill>
-                  <a:schemeClr val="bg1"/>
-                </a:solidFill>
-              </a:rPr>
-              <a:t>Built for screen readers</a:t>
-            </a:r>
-            <a:endParaRPr lang="en-US" sz="1300" dirty="0"/>
-          </a:p>
-        </p:txBody>
-      </p:sp>
-      <p:sp>
-        <p:nvSpPr>
-          <p:cNvPr id="7" name="Chip 3"/>
-          <p:cNvSpPr txBox="1"/>
-          <p:nvPr/>
-        </p:nvSpPr>
-        <p:spPr>
-          <a:xfrm>
-            <a:off x="5943600" y="5120640"/>
-            <a:ext cx="2514600" cy="457200"/>
-          </a:xfrm>
-          <a:prstGeom prst="roundRect">
-            <a:avLst>
-              <a:gd name="adj" fmla="val 16000"/>
-            </a:avLst>
-          </a:prstGeom>
-          <a:solidFill>
-            <a:srgbClr val="1E293B"/>
-          </a:solidFill>
-          <a:ln/>
-        </p:spPr>
-        <p:txBody>
-          <a:bodyPr wrap="square" lIns="50800" tIns="50800" rIns="50800" bIns="50800" rtlCol="0" anchor="ctr"/>
-          <a:lstStyle/>
-          <a:p>
-            <a:pPr algn="ctr" indent="0" marL="0">
-              <a:buNone/>
-            </a:pPr>
-            <a:r>
-              <a:rPr lang="en-US" sz="1300" b="1" dirty="0">
-                <a:solidFill>
-                  <a:schemeClr val="bg1"/>
-                </a:solidFill>
-              </a:rPr>
-              <a:t>Verifies its own work</a:t>
-            </a:r>
-            <a:endParaRPr lang="en-US" sz="1300" dirty="0"/>
+              <a:t>Job hunting with a screen reader takes hours.</a:t>
+            </a:r>
+            <a:endParaRPr lang="en-US" sz="2000" dirty="0"/>
           </a:p>
         </p:txBody>
       </p:sp>
@@ -2245,7 +2122,7 @@
         </p:nvSpPr>
         <p:spPr>
           <a:xfrm>
-            <a:off x="7406640" y="1325880"/>
+            <a:off x="7406640" y="1417320"/>
             <a:ext cx="4206240" cy="320040"/>
           </a:xfrm>
           <a:prstGeom prst="rect">
@@ -2262,47 +2139,247 @@
               <a:buNone/>
             </a:pPr>
             <a:r>
-              <a:rPr lang="en-US" sz="1400" b="1" dirty="0">
-                <a:solidFill>
-                  <a:schemeClr val="accent1"/>
+              <a:rPr lang="en-US" sz="1300" dirty="0">
+                <a:solidFill>
+                  <a:schemeClr val="bg2"/>
                 </a:solidFill>
               </a:rPr>
               <a:t>From her sentence</a:t>
             </a:r>
-            <a:endParaRPr lang="en-US" sz="1400" dirty="0"/>
-          </a:p>
-        </p:txBody>
-      </p:sp>
-      <p:sp>
-        <p:nvSpPr>
-          <p:cNvPr id="6" name="Dot 1"/>
-          <p:cNvSpPr/>
-          <p:nvPr/>
-        </p:nvSpPr>
-        <p:spPr>
-          <a:xfrm>
-            <a:off x="7406640" y="1828800"/>
-            <a:ext cx="146304" cy="146304"/>
-          </a:xfrm>
-          <a:prstGeom prst="ellipse">
-            <a:avLst/>
-          </a:prstGeom>
-          <a:solidFill>
-            <a:srgbClr val="3B82F6"/>
-          </a:solidFill>
-          <a:ln/>
-        </p:spPr>
-      </p:sp>
-      <p:sp>
-        <p:nvSpPr>
-          <p:cNvPr id="7" name="Need 1"/>
+            <a:endParaRPr lang="en-US" sz="1300" dirty="0"/>
+          </a:p>
+        </p:txBody>
+      </p:sp>
+      <p:sp>
+        <p:nvSpPr>
+          <p:cNvPr id="6" name="Need 1"/>
           <p:cNvSpPr txBox="1"/>
           <p:nvPr/>
         </p:nvSpPr>
         <p:spPr>
           <a:xfrm>
-            <a:off x="7680960" y="1737360"/>
-            <a:ext cx="3931920" cy="548640"/>
+            <a:off x="7406640" y="1783080"/>
+            <a:ext cx="4206240" cy="502920"/>
+          </a:xfrm>
+          <a:prstGeom prst="roundRect">
+            <a:avLst>
+              <a:gd name="adj" fmla="val 14545"/>
+            </a:avLst>
+          </a:prstGeom>
+          <a:solidFill>
+            <a:srgbClr val="1E293B"/>
+          </a:solidFill>
+          <a:ln w="15875">
+            <a:solidFill>
+              <a:srgbClr val="3B82F6"/>
+            </a:solidFill>
+          </a:ln>
+        </p:spPr>
+        <p:txBody>
+          <a:bodyPr wrap="square" lIns="152400" tIns="152400" rIns="152400" bIns="152400" rtlCol="0" anchor="ctr"/>
+          <a:lstStyle/>
+          <a:p>
+            <a:pPr algn="l" indent="0" marL="0">
+              <a:buNone/>
+            </a:pPr>
+            <a:r>
+              <a:rPr lang="en-US" sz="1600" b="1" dirty="0">
+                <a:solidFill>
+                  <a:schemeClr val="bg1"/>
+                </a:solidFill>
+              </a:rPr>
+              <a:t>Blind, uses NVDA</a:t>
+            </a:r>
+            <a:endParaRPr lang="en-US" sz="1600" dirty="0"/>
+          </a:p>
+        </p:txBody>
+      </p:sp>
+      <p:sp>
+        <p:nvSpPr>
+          <p:cNvPr id="7" name="Need 2"/>
+          <p:cNvSpPr txBox="1"/>
+          <p:nvPr/>
+        </p:nvSpPr>
+        <p:spPr>
+          <a:xfrm>
+            <a:off x="7406640" y="2404872"/>
+            <a:ext cx="4206240" cy="502920"/>
+          </a:xfrm>
+          <a:prstGeom prst="roundRect">
+            <a:avLst>
+              <a:gd name="adj" fmla="val 14545"/>
+            </a:avLst>
+          </a:prstGeom>
+          <a:solidFill>
+            <a:srgbClr val="1E293B"/>
+          </a:solidFill>
+          <a:ln w="15875">
+            <a:solidFill>
+              <a:srgbClr val="3B82F6"/>
+            </a:solidFill>
+          </a:ln>
+        </p:spPr>
+        <p:txBody>
+          <a:bodyPr wrap="square" lIns="152400" tIns="152400" rIns="152400" bIns="152400" rtlCol="0" anchor="ctr"/>
+          <a:lstStyle/>
+          <a:p>
+            <a:pPr algn="l" indent="0" marL="0">
+              <a:buNone/>
+            </a:pPr>
+            <a:r>
+              <a:rPr lang="en-US" sz="1600" b="1" dirty="0">
+                <a:solidFill>
+                  <a:schemeClr val="bg1"/>
+                </a:solidFill>
+              </a:rPr>
+              <a:t>Subang Jaya</a:t>
+            </a:r>
+            <a:endParaRPr lang="en-US" sz="1600" dirty="0"/>
+          </a:p>
+        </p:txBody>
+      </p:sp>
+      <p:sp>
+        <p:nvSpPr>
+          <p:cNvPr id="8" name="Need 3"/>
+          <p:cNvSpPr txBox="1"/>
+          <p:nvPr/>
+        </p:nvSpPr>
+        <p:spPr>
+          <a:xfrm>
+            <a:off x="7406640" y="3026664"/>
+            <a:ext cx="4206240" cy="502920"/>
+          </a:xfrm>
+          <a:prstGeom prst="roundRect">
+            <a:avLst>
+              <a:gd name="adj" fmla="val 14545"/>
+            </a:avLst>
+          </a:prstGeom>
+          <a:solidFill>
+            <a:srgbClr val="1E293B"/>
+          </a:solidFill>
+          <a:ln w="15875">
+            <a:solidFill>
+              <a:srgbClr val="3B82F6"/>
+            </a:solidFill>
+          </a:ln>
+        </p:spPr>
+        <p:txBody>
+          <a:bodyPr wrap="square" lIns="152400" tIns="152400" rIns="152400" bIns="152400" rtlCol="0" anchor="ctr"/>
+          <a:lstStyle/>
+          <a:p>
+            <a:pPr algn="l" indent="0" marL="0">
+              <a:buNone/>
+            </a:pPr>
+            <a:r>
+              <a:rPr lang="en-US" sz="1600" b="1" dirty="0">
+                <a:solidFill>
+                  <a:schemeClr val="bg1"/>
+                </a:solidFill>
+              </a:rPr>
+              <a:t>English, Malay, typing</a:t>
+            </a:r>
+            <a:endParaRPr lang="en-US" sz="1600" dirty="0"/>
+          </a:p>
+        </p:txBody>
+      </p:sp>
+      <p:sp>
+        <p:nvSpPr>
+          <p:cNvPr id="9" name="Need 4"/>
+          <p:cNvSpPr txBox="1"/>
+          <p:nvPr/>
+        </p:nvSpPr>
+        <p:spPr>
+          <a:xfrm>
+            <a:off x="7406640" y="3648456"/>
+            <a:ext cx="4206240" cy="502920"/>
+          </a:xfrm>
+          <a:prstGeom prst="roundRect">
+            <a:avLst>
+              <a:gd name="adj" fmla="val 14545"/>
+            </a:avLst>
+          </a:prstGeom>
+          <a:solidFill>
+            <a:srgbClr val="1E293B"/>
+          </a:solidFill>
+          <a:ln w="15875">
+            <a:solidFill>
+              <a:srgbClr val="3B82F6"/>
+            </a:solidFill>
+          </a:ln>
+        </p:spPr>
+        <p:txBody>
+          <a:bodyPr wrap="square" lIns="152400" tIns="152400" rIns="152400" bIns="152400" rtlCol="0" anchor="ctr"/>
+          <a:lstStyle/>
+          <a:p>
+            <a:pPr algn="l" indent="0" marL="0">
+              <a:buNone/>
+            </a:pPr>
+            <a:r>
+              <a:rPr lang="en-US" sz="1600" b="1" dirty="0">
+                <a:solidFill>
+                  <a:schemeClr val="bg1"/>
+                </a:solidFill>
+              </a:rPr>
+              <a:t>Weekdays 9 to 5</a:t>
+            </a:r>
+            <a:endParaRPr lang="en-US" sz="1600" dirty="0"/>
+          </a:p>
+        </p:txBody>
+      </p:sp>
+      <p:sp>
+        <p:nvSpPr>
+          <p:cNvPr id="10" name="Need 5"/>
+          <p:cNvSpPr txBox="1"/>
+          <p:nvPr/>
+        </p:nvSpPr>
+        <p:spPr>
+          <a:xfrm>
+            <a:off x="7406640" y="4270248"/>
+            <a:ext cx="4206240" cy="502920"/>
+          </a:xfrm>
+          <a:prstGeom prst="roundRect">
+            <a:avLst>
+              <a:gd name="adj" fmla="val 14545"/>
+            </a:avLst>
+          </a:prstGeom>
+          <a:solidFill>
+            <a:srgbClr val="1E293B"/>
+          </a:solidFill>
+          <a:ln w="15875">
+            <a:solidFill>
+              <a:srgbClr val="3B82F6"/>
+            </a:solidFill>
+          </a:ln>
+        </p:spPr>
+        <p:txBody>
+          <a:bodyPr wrap="square" lIns="152400" tIns="152400" rIns="152400" bIns="152400" rtlCol="0" anchor="ctr"/>
+          <a:lstStyle/>
+          <a:p>
+            <a:pPr algn="l" indent="0" marL="0">
+              <a:buNone/>
+            </a:pPr>
+            <a:r>
+              <a:rPr lang="en-US" sz="1600" b="1" dirty="0">
+                <a:solidFill>
+                  <a:schemeClr val="bg1"/>
+                </a:solidFill>
+              </a:rPr>
+              <a:t>RM12/hr minimum</a:t>
+            </a:r>
+            <a:endParaRPr lang="en-US" sz="1600" dirty="0"/>
+          </a:p>
+        </p:txBody>
+      </p:sp>
+      <p:sp>
+        <p:nvSpPr>
+          <p:cNvPr id="11" name="Group 2"/>
+          <p:cNvSpPr txBox="1"/>
+          <p:nvPr/>
+        </p:nvSpPr>
+        <p:spPr>
+          <a:xfrm>
+            <a:off x="7406640" y="4983480"/>
+            <a:ext cx="4206240" cy="320040"/>
           </a:xfrm>
           <a:prstGeom prst="rect">
             <a:avLst/>
@@ -2311,421 +2388,65 @@
           <a:ln/>
         </p:spPr>
         <p:txBody>
-          <a:bodyPr wrap="square" lIns="0" tIns="0" rIns="0" bIns="0" rtlCol="0" anchor="t"/>
+          <a:bodyPr wrap="square" lIns="0" tIns="0" rIns="0" bIns="0" rtlCol="0" anchor="ctr"/>
           <a:lstStyle/>
           <a:p>
             <a:pPr indent="0" marL="0">
               <a:buNone/>
             </a:pPr>
             <a:r>
-              <a:rPr lang="en-US" sz="1500" b="1" dirty="0">
-                <a:solidFill>
-                  <a:schemeClr val="bg1"/>
-                </a:solidFill>
-              </a:rPr>
-              <a:t>Blind, uses NVDA</a:t>
-            </a:r>
-            <a:endParaRPr lang="en-US" sz="1500" dirty="0"/>
-          </a:p>
-          <a:p>
-            <a:pPr indent="0" marL="0">
-              <a:buNone/>
-            </a:pPr>
-            <a:r>
-              <a:rPr lang="en-US" sz="1200" dirty="0">
+              <a:rPr lang="en-US" sz="1300" dirty="0">
                 <a:solidFill>
                   <a:schemeClr val="bg2"/>
                 </a:solidFill>
               </a:rPr>
-              <a:t>no tasks that need sight</a:t>
-            </a:r>
-            <a:endParaRPr lang="en-US" sz="1500" dirty="0"/>
-          </a:p>
-        </p:txBody>
-      </p:sp>
-      <p:sp>
-        <p:nvSpPr>
-          <p:cNvPr id="8" name="Dot 2"/>
-          <p:cNvSpPr/>
-          <p:nvPr/>
-        </p:nvSpPr>
-        <p:spPr>
-          <a:xfrm>
-            <a:off x="7406640" y="2432304"/>
-            <a:ext cx="146304" cy="146304"/>
-          </a:xfrm>
-          <a:prstGeom prst="ellipse">
-            <a:avLst/>
-          </a:prstGeom>
-          <a:solidFill>
-            <a:srgbClr val="3B82F6"/>
-          </a:solidFill>
-          <a:ln/>
-        </p:spPr>
-      </p:sp>
-      <p:sp>
-        <p:nvSpPr>
-          <p:cNvPr id="9" name="Need 2"/>
+              <a:t>From her resume</a:t>
+            </a:r>
+            <a:endParaRPr lang="en-US" sz="1300" dirty="0"/>
+          </a:p>
+        </p:txBody>
+      </p:sp>
+      <p:sp>
+        <p:nvSpPr>
+          <p:cNvPr id="12" name="Need 6"/>
           <p:cNvSpPr txBox="1"/>
           <p:nvPr/>
         </p:nvSpPr>
         <p:spPr>
           <a:xfrm>
-            <a:off x="7680960" y="2340864"/>
-            <a:ext cx="3931920" cy="548640"/>
-          </a:xfrm>
-          <a:prstGeom prst="rect">
-            <a:avLst/>
-          </a:prstGeom>
-          <a:noFill/>
-          <a:ln/>
-        </p:spPr>
-        <p:txBody>
-          <a:bodyPr wrap="square" lIns="0" tIns="0" rIns="0" bIns="0" rtlCol="0" anchor="t"/>
-          <a:lstStyle/>
-          <a:p>
-            <a:pPr indent="0" marL="0">
-              <a:buNone/>
-            </a:pPr>
-            <a:r>
-              <a:rPr lang="en-US" sz="1500" b="1" dirty="0">
-                <a:solidFill>
-                  <a:schemeClr val="bg1"/>
-                </a:solidFill>
-              </a:rPr>
-              <a:t>Subang Jaya</a:t>
-            </a:r>
-            <a:endParaRPr lang="en-US" sz="1500" dirty="0"/>
-          </a:p>
-          <a:p>
-            <a:pPr indent="0" marL="0">
-              <a:buNone/>
-            </a:pPr>
-            <a:r>
-              <a:rPr lang="en-US" sz="1200" dirty="0">
-                <a:solidFill>
-                  <a:schemeClr val="bg2"/>
-                </a:solidFill>
-              </a:rPr>
-              <a:t>near a train stop</a:t>
-            </a:r>
-            <a:endParaRPr lang="en-US" sz="1500" dirty="0"/>
-          </a:p>
-        </p:txBody>
-      </p:sp>
-      <p:sp>
-        <p:nvSpPr>
-          <p:cNvPr id="10" name="Dot 3"/>
-          <p:cNvSpPr/>
-          <p:nvPr/>
-        </p:nvSpPr>
-        <p:spPr>
-          <a:xfrm>
-            <a:off x="7406640" y="3035808"/>
-            <a:ext cx="146304" cy="146304"/>
-          </a:xfrm>
-          <a:prstGeom prst="ellipse">
-            <a:avLst/>
-          </a:prstGeom>
-          <a:solidFill>
-            <a:srgbClr val="3B82F6"/>
-          </a:solidFill>
-          <a:ln/>
-        </p:spPr>
-      </p:sp>
-      <p:sp>
-        <p:nvSpPr>
-          <p:cNvPr id="11" name="Need 3"/>
-          <p:cNvSpPr txBox="1"/>
-          <p:nvPr/>
-        </p:nvSpPr>
-        <p:spPr>
-          <a:xfrm>
-            <a:off x="7680960" y="2944368"/>
-            <a:ext cx="3931920" cy="548640"/>
-          </a:xfrm>
-          <a:prstGeom prst="rect">
-            <a:avLst/>
-          </a:prstGeom>
-          <a:noFill/>
-          <a:ln/>
-        </p:spPr>
-        <p:txBody>
-          <a:bodyPr wrap="square" lIns="0" tIns="0" rIns="0" bIns="0" rtlCol="0" anchor="t"/>
-          <a:lstStyle/>
-          <a:p>
-            <a:pPr indent="0" marL="0">
-              <a:buNone/>
-            </a:pPr>
-            <a:r>
-              <a:rPr lang="en-US" sz="1500" b="1" dirty="0">
-                <a:solidFill>
-                  <a:schemeClr val="bg1"/>
-                </a:solidFill>
-              </a:rPr>
-              <a:t>English, Malay, fast typing</a:t>
-            </a:r>
-            <a:endParaRPr lang="en-US" sz="1500" dirty="0"/>
-          </a:p>
-          <a:p>
-            <a:pPr indent="0" marL="0">
-              <a:buNone/>
-            </a:pPr>
-            <a:r>
-              <a:rPr lang="en-US" sz="1200" dirty="0">
-                <a:solidFill>
-                  <a:schemeClr val="bg2"/>
-                </a:solidFill>
-              </a:rPr>
-              <a:t>skills matched to each job</a:t>
-            </a:r>
-            <a:endParaRPr lang="en-US" sz="1500" dirty="0"/>
-          </a:p>
-        </p:txBody>
-      </p:sp>
-      <p:sp>
-        <p:nvSpPr>
-          <p:cNvPr id="12" name="Dot 4"/>
-          <p:cNvSpPr/>
-          <p:nvPr/>
-        </p:nvSpPr>
-        <p:spPr>
-          <a:xfrm>
-            <a:off x="7406640" y="3639312"/>
-            <a:ext cx="146304" cy="146304"/>
-          </a:xfrm>
-          <a:prstGeom prst="ellipse">
-            <a:avLst/>
-          </a:prstGeom>
-          <a:solidFill>
-            <a:srgbClr val="3B82F6"/>
-          </a:solidFill>
-          <a:ln/>
-        </p:spPr>
-      </p:sp>
-      <p:sp>
-        <p:nvSpPr>
-          <p:cNvPr id="13" name="Need 4"/>
-          <p:cNvSpPr txBox="1"/>
-          <p:nvPr/>
-        </p:nvSpPr>
-        <p:spPr>
-          <a:xfrm>
-            <a:off x="7680960" y="3547872"/>
-            <a:ext cx="3931920" cy="548640"/>
-          </a:xfrm>
-          <a:prstGeom prst="rect">
-            <a:avLst/>
-          </a:prstGeom>
-          <a:noFill/>
-          <a:ln/>
-        </p:spPr>
-        <p:txBody>
-          <a:bodyPr wrap="square" lIns="0" tIns="0" rIns="0" bIns="0" rtlCol="0" anchor="t"/>
-          <a:lstStyle/>
-          <a:p>
-            <a:pPr indent="0" marL="0">
-              <a:buNone/>
-            </a:pPr>
-            <a:r>
-              <a:rPr lang="en-US" sz="1500" b="1" dirty="0">
-                <a:solidFill>
-                  <a:schemeClr val="bg1"/>
-                </a:solidFill>
-              </a:rPr>
-              <a:t>Weekdays 9 to 5</a:t>
-            </a:r>
-            <a:endParaRPr lang="en-US" sz="1500" dirty="0"/>
-          </a:p>
-          <a:p>
-            <a:pPr indent="0" marL="0">
-              <a:buNone/>
-            </a:pPr>
-            <a:r>
-              <a:rPr lang="en-US" sz="1200" dirty="0">
-                <a:solidFill>
-                  <a:schemeClr val="bg2"/>
-                </a:solidFill>
-              </a:rPr>
-              <a:t>shift must fit</a:t>
-            </a:r>
-            <a:endParaRPr lang="en-US" sz="1500" dirty="0"/>
-          </a:p>
-        </p:txBody>
-      </p:sp>
-      <p:sp>
-        <p:nvSpPr>
-          <p:cNvPr id="14" name="Dot 5"/>
-          <p:cNvSpPr/>
-          <p:nvPr/>
-        </p:nvSpPr>
-        <p:spPr>
-          <a:xfrm>
-            <a:off x="7406640" y="4242816"/>
-            <a:ext cx="146304" cy="146304"/>
-          </a:xfrm>
-          <a:prstGeom prst="ellipse">
-            <a:avLst/>
-          </a:prstGeom>
-          <a:solidFill>
-            <a:srgbClr val="3B82F6"/>
-          </a:solidFill>
-          <a:ln/>
-        </p:spPr>
-      </p:sp>
-      <p:sp>
-        <p:nvSpPr>
-          <p:cNvPr id="15" name="Need 5"/>
-          <p:cNvSpPr txBox="1"/>
-          <p:nvPr/>
-        </p:nvSpPr>
-        <p:spPr>
-          <a:xfrm>
-            <a:off x="7680960" y="4151376"/>
-            <a:ext cx="3931920" cy="548640"/>
-          </a:xfrm>
-          <a:prstGeom prst="rect">
-            <a:avLst/>
-          </a:prstGeom>
-          <a:noFill/>
-          <a:ln/>
-        </p:spPr>
-        <p:txBody>
-          <a:bodyPr wrap="square" lIns="0" tIns="0" rIns="0" bIns="0" rtlCol="0" anchor="t"/>
-          <a:lstStyle/>
-          <a:p>
-            <a:pPr indent="0" marL="0">
-              <a:buNone/>
-            </a:pPr>
-            <a:r>
-              <a:rPr lang="en-US" sz="1500" b="1" dirty="0">
-                <a:solidFill>
-                  <a:schemeClr val="bg1"/>
-                </a:solidFill>
-              </a:rPr>
-              <a:t>RM12/hr minimum</a:t>
-            </a:r>
-            <a:endParaRPr lang="en-US" sz="1500" dirty="0"/>
-          </a:p>
-          <a:p>
-            <a:pPr indent="0" marL="0">
-              <a:buNone/>
-            </a:pPr>
-            <a:r>
-              <a:rPr lang="en-US" sz="1200" dirty="0">
-                <a:solidFill>
-                  <a:schemeClr val="bg2"/>
-                </a:solidFill>
-              </a:rPr>
-              <a:t>and never below RM8.72 legal</a:t>
-            </a:r>
-            <a:endParaRPr lang="en-US" sz="1500" dirty="0"/>
-          </a:p>
-        </p:txBody>
-      </p:sp>
-      <p:sp>
-        <p:nvSpPr>
-          <p:cNvPr id="16" name="Group 2"/>
-          <p:cNvSpPr txBox="1"/>
-          <p:nvPr/>
-        </p:nvSpPr>
-        <p:spPr>
-          <a:xfrm>
-            <a:off x="7406640" y="4892040"/>
-            <a:ext cx="4206240" cy="320040"/>
-          </a:xfrm>
-          <a:prstGeom prst="rect">
-            <a:avLst/>
-          </a:prstGeom>
-          <a:noFill/>
-          <a:ln/>
-        </p:spPr>
-        <p:txBody>
-          <a:bodyPr wrap="square" lIns="0" tIns="0" rIns="0" bIns="0" rtlCol="0" anchor="ctr"/>
-          <a:lstStyle/>
-          <a:p>
-            <a:pPr indent="0" marL="0">
-              <a:buNone/>
-            </a:pPr>
-            <a:r>
-              <a:rPr lang="en-US" sz="1400" b="1" dirty="0">
+            <a:off x="7406640" y="5349240"/>
+            <a:ext cx="4206240" cy="502920"/>
+          </a:xfrm>
+          <a:prstGeom prst="roundRect">
+            <a:avLst>
+              <a:gd name="adj" fmla="val 14545"/>
+            </a:avLst>
+          </a:prstGeom>
+          <a:solidFill>
+            <a:srgbClr val="1E293B"/>
+          </a:solidFill>
+          <a:ln w="15875">
+            <a:solidFill>
+              <a:srgbClr val="10B981"/>
+            </a:solidFill>
+          </a:ln>
+        </p:spPr>
+        <p:txBody>
+          <a:bodyPr wrap="square" lIns="152400" tIns="152400" rIns="152400" bIns="152400" rtlCol="0" anchor="ctr"/>
+          <a:lstStyle/>
+          <a:p>
+            <a:pPr algn="l" indent="0" marL="0">
+              <a:buNone/>
+            </a:pPr>
+            <a:r>
+              <a:rPr lang="en-US" sz="1600" b="1" dirty="0">
                 <a:solidFill>
                   <a:schemeClr val="accent2"/>
                 </a:solidFill>
               </a:rPr>
-              <a:t>From her resume, read by WorkBuddy</a:t>
-            </a:r>
-            <a:endParaRPr lang="en-US" sz="1400" dirty="0"/>
-          </a:p>
-        </p:txBody>
-      </p:sp>
-      <p:sp>
-        <p:nvSpPr>
-          <p:cNvPr id="17" name="Dot 6"/>
-          <p:cNvSpPr/>
-          <p:nvPr/>
-        </p:nvSpPr>
-        <p:spPr>
-          <a:xfrm>
-            <a:off x="7406640" y="5394960"/>
-            <a:ext cx="146304" cy="146304"/>
-          </a:xfrm>
-          <a:prstGeom prst="ellipse">
-            <a:avLst/>
-          </a:prstGeom>
-          <a:solidFill>
-            <a:srgbClr val="10B981"/>
-          </a:solidFill>
-          <a:ln/>
-        </p:spPr>
-      </p:sp>
-      <p:sp>
-        <p:nvSpPr>
-          <p:cNvPr id="18" name="Need 6"/>
-          <p:cNvSpPr txBox="1"/>
-          <p:nvPr/>
-        </p:nvSpPr>
-        <p:spPr>
-          <a:xfrm>
-            <a:off x="7680960" y="5303520"/>
-            <a:ext cx="3931920" cy="548640"/>
-          </a:xfrm>
-          <a:prstGeom prst="rect">
-            <a:avLst/>
-          </a:prstGeom>
-          <a:noFill/>
-          <a:ln/>
-        </p:spPr>
-        <p:txBody>
-          <a:bodyPr wrap="square" lIns="0" tIns="0" rIns="0" bIns="0" rtlCol="0" anchor="t"/>
-          <a:lstStyle/>
-          <a:p>
-            <a:pPr indent="0" marL="0">
-              <a:buNone/>
-            </a:pPr>
-            <a:r>
-              <a:rPr lang="en-US" sz="1500" b="1" dirty="0">
-                <a:solidFill>
-                  <a:schemeClr val="bg1"/>
-                </a:solidFill>
-              </a:rPr>
               <a:t>Bank hotline, 1 year</a:t>
             </a:r>
-            <a:endParaRPr lang="en-US" sz="1500" dirty="0"/>
-          </a:p>
-          <a:p>
-            <a:pPr indent="0" marL="0">
-              <a:buNone/>
-            </a:pPr>
-            <a:r>
-              <a:rPr lang="en-US" sz="1200" dirty="0">
-                <a:solidFill>
-                  <a:schemeClr val="bg2"/>
-                </a:solidFill>
-              </a:rPr>
-              <a:t>saved to her profile for her application</a:t>
-            </a:r>
-            <a:endParaRPr lang="en-US" sz="1500" dirty="0"/>
+            <a:endParaRPr lang="en-US" sz="1600" dirty="0"/>
           </a:p>
         </p:txBody>
       </p:sp>
@@ -2839,50 +2560,14 @@
       </p:sp>
       <p:sp>
         <p:nvSpPr>
-          <p:cNvPr id="3" name="Subtitle"/>
+          <p:cNvPr id="3" name="Prompt"/>
           <p:cNvSpPr txBox="1"/>
           <p:nvPr/>
         </p:nvSpPr>
         <p:spPr>
           <a:xfrm>
-            <a:off x="548640" y="1005840"/>
-            <a:ext cx="10972800" cy="411480"/>
-          </a:xfrm>
-          <a:prstGeom prst="rect">
-            <a:avLst/>
-          </a:prstGeom>
-          <a:noFill/>
-          <a:ln/>
-        </p:spPr>
-        <p:txBody>
-          <a:bodyPr wrap="square" lIns="0" tIns="0" rIns="0" bIns="0" rtlCol="0" anchor="ctr"/>
-          <a:lstStyle/>
-          <a:p>
-            <a:pPr indent="0" marL="0">
-              <a:buNone/>
-            </a:pPr>
-            <a:r>
-              <a:rPr lang="en-US" sz="1500" dirty="0">
-                <a:solidFill>
-                  <a:schemeClr val="bg2"/>
-                </a:solidFill>
-              </a:rPr>
-              <a:t>Our skill drives WorkBuddy end to end: its file access, web search and email, plus our MCP tools.</a:t>
-            </a:r>
-            <a:endParaRPr lang="en-US" sz="1500" dirty="0"/>
-          </a:p>
-        </p:txBody>
-      </p:sp>
-      <p:sp>
-        <p:nvSpPr>
-          <p:cNvPr id="4" name="WorkBuddy prompt"/>
-          <p:cNvSpPr txBox="1"/>
-          <p:nvPr/>
-        </p:nvSpPr>
-        <p:spPr>
-          <a:xfrm>
-            <a:off x="548640" y="2011680"/>
-            <a:ext cx="1325880" cy="914400"/>
+            <a:off x="548640" y="2103120"/>
+            <a:ext cx="1463040" cy="914400"/>
           </a:xfrm>
           <a:prstGeom prst="roundRect">
             <a:avLst>
@@ -2902,41 +2587,27 @@
               <a:buNone/>
             </a:pPr>
             <a:r>
-              <a:rPr lang="en-US" sz="1200" b="1" dirty="0">
+              <a:rPr lang="en-US" sz="1400" b="1" dirty="0">
                 <a:solidFill>
                   <a:schemeClr val="bg1"/>
                 </a:solidFill>
               </a:rPr>
-              <a:t>WorkBuddy</a:t>
-            </a:r>
-            <a:endParaRPr lang="en-US" sz="1200" dirty="0"/>
-          </a:p>
-          <a:p>
-            <a:pPr algn="ctr" indent="0" marL="0">
-              <a:buNone/>
-            </a:pPr>
-            <a:r>
-              <a:rPr lang="en-US" sz="1200" b="1" dirty="0">
-                <a:solidFill>
-                  <a:schemeClr val="bg1"/>
-                </a:solidFill>
-              </a:rPr>
-              <a:t>her sentence</a:t>
-            </a:r>
-            <a:endParaRPr lang="en-US" sz="1200" dirty="0"/>
-          </a:p>
-        </p:txBody>
-      </p:sp>
-      <p:sp>
-        <p:nvSpPr>
-          <p:cNvPr id="5" name="Arrow 1"/>
+              <a:t>Her sentence</a:t>
+            </a:r>
+            <a:endParaRPr lang="en-US" sz="1400" dirty="0"/>
+          </a:p>
+        </p:txBody>
+      </p:sp>
+      <p:sp>
+        <p:nvSpPr>
+          <p:cNvPr id="4" name="Arrow 1"/>
           <p:cNvSpPr/>
           <p:nvPr/>
         </p:nvSpPr>
         <p:spPr>
           <a:xfrm>
-            <a:off x="1874520" y="2468880"/>
-            <a:ext cx="256032" cy="0"/>
+            <a:off x="2011680" y="2560320"/>
+            <a:ext cx="274320" cy="0"/>
           </a:xfrm>
           <a:prstGeom prst="line">
             <a:avLst/>
@@ -2953,14 +2624,14 @@
       </p:sp>
       <p:sp>
         <p:nvSpPr>
-          <p:cNvPr id="6" name="Find resume"/>
+          <p:cNvPr id="5" name="Find resume"/>
           <p:cNvSpPr txBox="1"/>
           <p:nvPr/>
         </p:nvSpPr>
         <p:spPr>
           <a:xfrm>
-            <a:off x="2130552" y="2011680"/>
-            <a:ext cx="1554480" cy="914400"/>
+            <a:off x="2286000" y="2103120"/>
+            <a:ext cx="1463040" cy="914400"/>
           </a:xfrm>
           <a:prstGeom prst="roundRect">
             <a:avLst>
@@ -2980,55 +2651,27 @@
               <a:buNone/>
             </a:pPr>
             <a:r>
-              <a:rPr lang="en-US" sz="1100" b="1" dirty="0">
+              <a:rPr lang="en-US" sz="1400" b="1" dirty="0">
                 <a:solidFill>
                   <a:schemeClr val="bg1"/>
                 </a:solidFill>
               </a:rPr>
-              <a:t>Finds + reads</a:t>
-            </a:r>
-            <a:endParaRPr lang="en-US" sz="1100" dirty="0"/>
-          </a:p>
-          <a:p>
-            <a:pPr algn="ctr" indent="0" marL="0">
-              <a:buNone/>
-            </a:pPr>
-            <a:r>
-              <a:rPr lang="en-US" sz="1100" b="1" dirty="0">
-                <a:solidFill>
-                  <a:schemeClr val="bg1"/>
-                </a:solidFill>
-              </a:rPr>
-              <a:t>her resume in</a:t>
-            </a:r>
-            <a:endParaRPr lang="en-US" sz="1100" dirty="0"/>
-          </a:p>
-          <a:p>
-            <a:pPr algn="ctr" indent="0" marL="0">
-              <a:buNone/>
-            </a:pPr>
-            <a:r>
-              <a:rPr lang="en-US" sz="1100" b="1" dirty="0">
-                <a:solidFill>
-                  <a:schemeClr val="bg1"/>
-                </a:solidFill>
-              </a:rPr>
-              <a:t>Documents</a:t>
-            </a:r>
-            <a:endParaRPr lang="en-US" sz="1100" dirty="0"/>
-          </a:p>
-        </p:txBody>
-      </p:sp>
-      <p:sp>
-        <p:nvSpPr>
-          <p:cNvPr id="7" name="Arrow 2"/>
+              <a:t>Reads her resume</a:t>
+            </a:r>
+            <a:endParaRPr lang="en-US" sz="1400" dirty="0"/>
+          </a:p>
+        </p:txBody>
+      </p:sp>
+      <p:sp>
+        <p:nvSpPr>
+          <p:cNvPr id="6" name="Arrow 2"/>
           <p:cNvSpPr/>
           <p:nvPr/>
         </p:nvSpPr>
         <p:spPr>
           <a:xfrm>
-            <a:off x="3685032" y="2468880"/>
-            <a:ext cx="256032" cy="0"/>
+            <a:off x="3749040" y="2560320"/>
+            <a:ext cx="274320" cy="0"/>
           </a:xfrm>
           <a:prstGeom prst="line">
             <a:avLst/>
@@ -3045,14 +2688,14 @@
       </p:sp>
       <p:sp>
         <p:nvSpPr>
-          <p:cNvPr id="8" name="Search job sites"/>
+          <p:cNvPr id="7" name="Search job sites"/>
           <p:cNvSpPr txBox="1"/>
           <p:nvPr/>
         </p:nvSpPr>
         <p:spPr>
           <a:xfrm>
-            <a:off x="3941064" y="1600200"/>
-            <a:ext cx="2057400" cy="777240"/>
+            <a:off x="4023360" y="1600200"/>
+            <a:ext cx="1828800" cy="777240"/>
           </a:xfrm>
           <a:prstGeom prst="roundRect">
             <a:avLst>
@@ -3060,13 +2703,9 @@
             </a:avLst>
           </a:prstGeom>
           <a:solidFill>
-            <a:srgbClr val="1E293B"/>
-          </a:solidFill>
-          <a:ln w="12700">
-            <a:solidFill>
-              <a:srgbClr val="3B82F6"/>
-            </a:solidFill>
-          </a:ln>
+            <a:srgbClr val="1E40AF"/>
+          </a:solidFill>
+          <a:ln/>
         </p:spPr>
         <p:txBody>
           <a:bodyPr wrap="square" lIns="50800" tIns="50800" rIns="50800" bIns="50800" rtlCol="0" anchor="ctr"/>
@@ -3076,41 +2715,27 @@
               <a:buNone/>
             </a:pPr>
             <a:r>
-              <a:rPr lang="en-US" sz="1100" b="1" dirty="0">
+              <a:rPr lang="en-US" sz="1400" b="1" dirty="0">
                 <a:solidFill>
                   <a:schemeClr val="bg1"/>
                 </a:solidFill>
               </a:rPr>
-              <a:t>Searches JobStreet,</a:t>
-            </a:r>
-            <a:endParaRPr lang="en-US" sz="1100" dirty="0"/>
-          </a:p>
-          <a:p>
-            <a:pPr algn="ctr" indent="0" marL="0">
-              <a:buNone/>
-            </a:pPr>
-            <a:r>
-              <a:rPr lang="en-US" sz="1100" b="1" dirty="0">
-                <a:solidFill>
-                  <a:schemeClr val="bg1"/>
-                </a:solidFill>
-              </a:rPr>
-              <a:t>Indeed, Hiredly</a:t>
-            </a:r>
-            <a:endParaRPr lang="en-US" sz="1100" dirty="0"/>
-          </a:p>
-        </p:txBody>
-      </p:sp>
-      <p:sp>
-        <p:nvSpPr>
-          <p:cNvPr id="9" name="Understand"/>
+              <a:t>Searches job sites</a:t>
+            </a:r>
+            <a:endParaRPr lang="en-US" sz="1400" dirty="0"/>
+          </a:p>
+        </p:txBody>
+      </p:sp>
+      <p:sp>
+        <p:nvSpPr>
+          <p:cNvPr id="8" name="Understand"/>
           <p:cNvSpPr txBox="1"/>
           <p:nvPr/>
         </p:nvSpPr>
         <p:spPr>
           <a:xfrm>
-            <a:off x="3941064" y="2560320"/>
-            <a:ext cx="2057400" cy="777240"/>
+            <a:off x="4023360" y="2697480"/>
+            <a:ext cx="1828800" cy="777240"/>
           </a:xfrm>
           <a:prstGeom prst="roundRect">
             <a:avLst>
@@ -3130,77 +2755,63 @@
               <a:buNone/>
             </a:pPr>
             <a:r>
-              <a:rPr lang="en-US" sz="1100" b="1" dirty="0">
+              <a:rPr lang="en-US" sz="1400" b="1" dirty="0">
                 <a:solidFill>
                   <a:schemeClr val="bg1"/>
                 </a:solidFill>
               </a:rPr>
-              <a:t>hirebuddy_1_</a:t>
-            </a:r>
-            <a:endParaRPr lang="en-US" sz="1100" dirty="0"/>
-          </a:p>
+              <a:t>Saves profile</a:t>
+            </a:r>
+            <a:endParaRPr lang="en-US" sz="1400" dirty="0"/>
+          </a:p>
+        </p:txBody>
+      </p:sp>
+      <p:sp>
+        <p:nvSpPr>
+          <p:cNvPr id="9" name="Parallel label"/>
+          <p:cNvSpPr txBox="1"/>
+          <p:nvPr/>
+        </p:nvSpPr>
+        <p:spPr>
+          <a:xfrm>
+            <a:off x="4023360" y="3520440"/>
+            <a:ext cx="1828800" cy="274320"/>
+          </a:xfrm>
+          <a:prstGeom prst="rect">
+            <a:avLst/>
+          </a:prstGeom>
+          <a:noFill/>
+          <a:ln/>
+        </p:spPr>
+        <p:txBody>
+          <a:bodyPr wrap="square" lIns="0" tIns="0" rIns="0" bIns="0" rtlCol="0" anchor="ctr"/>
+          <a:lstStyle/>
           <a:p>
             <a:pPr algn="ctr" indent="0" marL="0">
               <a:buNone/>
             </a:pPr>
             <a:r>
-              <a:rPr lang="en-US" sz="1100" b="1" dirty="0">
-                <a:solidFill>
-                  <a:schemeClr val="bg1"/>
-                </a:solidFill>
-              </a:rPr>
-              <a:t>understand</a:t>
-            </a:r>
-            <a:endParaRPr lang="en-US" sz="1100" dirty="0"/>
-          </a:p>
-        </p:txBody>
-      </p:sp>
-      <p:sp>
-        <p:nvSpPr>
-          <p:cNvPr id="10" name="Parallel label"/>
-          <p:cNvSpPr txBox="1"/>
-          <p:nvPr/>
-        </p:nvSpPr>
-        <p:spPr>
-          <a:xfrm>
-            <a:off x="3941064" y="3401568"/>
-            <a:ext cx="2057400" cy="274320"/>
-          </a:xfrm>
-          <a:prstGeom prst="rect">
-            <a:avLst/>
-          </a:prstGeom>
-          <a:noFill/>
-          <a:ln/>
-        </p:spPr>
-        <p:txBody>
-          <a:bodyPr wrap="square" lIns="0" tIns="0" rIns="0" bIns="0" rtlCol="0" anchor="ctr"/>
-          <a:lstStyle/>
-          <a:p>
-            <a:pPr algn="ctr" indent="0" marL="0">
-              <a:buNone/>
-            </a:pPr>
-            <a:r>
-              <a:rPr lang="en-US" sz="1100" i="1" dirty="0">
+              <a:rPr lang="en-US" sz="1200" i="1" dirty="0">
                 <a:solidFill>
                   <a:schemeClr val="accent2"/>
                 </a:solidFill>
               </a:rPr>
               <a:t>in parallel</a:t>
             </a:r>
-            <a:endParaRPr lang="en-US" sz="1100" dirty="0"/>
-          </a:p>
-        </p:txBody>
-      </p:sp>
-      <p:sp>
-        <p:nvSpPr>
-          <p:cNvPr id="11" name="Arrow 3a"/>
+            <a:endParaRPr lang="en-US" sz="1200" dirty="0"/>
+          </a:p>
+        </p:txBody>
+      </p:sp>
+      <p:sp>
+        <p:nvSpPr>
+          <p:cNvPr id="10" name="Arrow 3a"/>
           <p:cNvSpPr/>
           <p:nvPr/>
         </p:nvSpPr>
         <p:spPr>
           <a:xfrm>
-            <a:off x="5998464" y="1984248"/>
-            <a:ext cx="292608" cy="411480"/>
+            <a:off x="5852160" y="1984248"/>
+            <a:ext cx="320040" cy="457200"/>
           </a:xfrm>
           <a:prstGeom prst="line">
             <a:avLst/>
@@ -3217,14 +2828,14 @@
       </p:sp>
       <p:sp>
         <p:nvSpPr>
-          <p:cNvPr id="12" name="Arrow 3b"/>
+          <p:cNvPr id="11" name="Arrow 3b"/>
           <p:cNvSpPr/>
           <p:nvPr/>
         </p:nvSpPr>
         <p:spPr>
           <a:xfrm flipV="1">
-            <a:off x="5998464" y="2532888"/>
-            <a:ext cx="292608" cy="411480"/>
+            <a:off x="5852160" y="2624328"/>
+            <a:ext cx="320040" cy="457200"/>
           </a:xfrm>
           <a:prstGeom prst="line">
             <a:avLst/>
@@ -3241,14 +2852,14 @@
       </p:sp>
       <p:sp>
         <p:nvSpPr>
-          <p:cNvPr id="13" name="Check jobs"/>
+          <p:cNvPr id="12" name="Check jobs"/>
           <p:cNvSpPr txBox="1"/>
           <p:nvPr/>
         </p:nvSpPr>
         <p:spPr>
           <a:xfrm>
-            <a:off x="6291072" y="2011680"/>
-            <a:ext cx="1783080" cy="914400"/>
+            <a:off x="6172200" y="2103120"/>
+            <a:ext cx="1645920" cy="914400"/>
           </a:xfrm>
           <a:prstGeom prst="roundRect">
             <a:avLst>
@@ -3268,55 +2879,27 @@
               <a:buNone/>
             </a:pPr>
             <a:r>
-              <a:rPr lang="en-US" sz="1100" b="1" dirty="0">
+              <a:rPr lang="en-US" sz="1400" b="1" dirty="0">
                 <a:solidFill>
                   <a:schemeClr val="bg1"/>
                 </a:solidFill>
               </a:rPr>
-              <a:t>hirebuddy_2_</a:t>
-            </a:r>
-            <a:endParaRPr lang="en-US" sz="1100" dirty="0"/>
-          </a:p>
-          <a:p>
-            <a:pPr algn="ctr" indent="0" marL="0">
-              <a:buNone/>
-            </a:pPr>
-            <a:r>
-              <a:rPr lang="en-US" sz="1100" b="1" dirty="0">
-                <a:solidFill>
-                  <a:schemeClr val="bg1"/>
-                </a:solidFill>
-              </a:rPr>
-              <a:t>check_jobs</a:t>
-            </a:r>
-            <a:endParaRPr lang="en-US" sz="1100" dirty="0"/>
-          </a:p>
-          <a:p>
-            <a:pPr algn="ctr" indent="0" marL="0">
-              <a:buNone/>
-            </a:pPr>
-            <a:r>
-              <a:rPr lang="en-US" sz="1100" b="1" dirty="0">
-                <a:solidFill>
-                  <a:schemeClr val="bg1"/>
-                </a:solidFill>
-              </a:rPr>
-              <a:t>pay, travel, sight</a:t>
-            </a:r>
-            <a:endParaRPr lang="en-US" sz="1100" dirty="0"/>
-          </a:p>
-        </p:txBody>
-      </p:sp>
-      <p:sp>
-        <p:nvSpPr>
-          <p:cNvPr id="14" name="Arrow 4"/>
+              <a:t>Checks every job</a:t>
+            </a:r>
+            <a:endParaRPr lang="en-US" sz="1400" dirty="0"/>
+          </a:p>
+        </p:txBody>
+      </p:sp>
+      <p:sp>
+        <p:nvSpPr>
+          <p:cNvPr id="13" name="Arrow 4"/>
           <p:cNvSpPr/>
           <p:nvPr/>
         </p:nvSpPr>
         <p:spPr>
           <a:xfrm>
-            <a:off x="8074152" y="2468880"/>
-            <a:ext cx="256032" cy="0"/>
+            <a:off x="7818120" y="2560320"/>
+            <a:ext cx="274320" cy="0"/>
           </a:xfrm>
           <a:prstGeom prst="line">
             <a:avLst/>
@@ -3333,14 +2916,14 @@
       </p:sp>
       <p:sp>
         <p:nvSpPr>
-          <p:cNvPr id="15" name="Verify"/>
+          <p:cNvPr id="14" name="Verify"/>
           <p:cNvSpPr txBox="1"/>
           <p:nvPr/>
         </p:nvSpPr>
         <p:spPr>
           <a:xfrm>
-            <a:off x="8330184" y="2011680"/>
-            <a:ext cx="1417320" cy="914400"/>
+            <a:off x="8092440" y="2103120"/>
+            <a:ext cx="1463040" cy="914400"/>
           </a:xfrm>
           <a:prstGeom prst="roundRect">
             <a:avLst>
@@ -3360,55 +2943,27 @@
               <a:buNone/>
             </a:pPr>
             <a:r>
-              <a:rPr lang="en-US" sz="1100" b="1" dirty="0">
+              <a:rPr lang="en-US" sz="1400" b="1" dirty="0">
                 <a:solidFill>
                   <a:schemeClr val="bg1"/>
                 </a:solidFill>
               </a:rPr>
-              <a:t>hirebuddy_4_</a:t>
-            </a:r>
-            <a:endParaRPr lang="en-US" sz="1100" dirty="0"/>
-          </a:p>
-          <a:p>
-            <a:pPr algn="ctr" indent="0" marL="0">
-              <a:buNone/>
-            </a:pPr>
-            <a:r>
-              <a:rPr lang="en-US" sz="1100" b="1" dirty="0">
-                <a:solidFill>
-                  <a:schemeClr val="bg1"/>
-                </a:solidFill>
-              </a:rPr>
-              <a:t>verify</a:t>
-            </a:r>
-            <a:endParaRPr lang="en-US" sz="1100" dirty="0"/>
-          </a:p>
-          <a:p>
-            <a:pPr algn="ctr" indent="0" marL="0">
-              <a:buNone/>
-            </a:pPr>
-            <a:r>
-              <a:rPr lang="en-US" sz="1100" b="1" dirty="0">
-                <a:solidFill>
-                  <a:schemeClr val="bg1"/>
-                </a:solidFill>
-              </a:rPr>
-              <a:t>must pass</a:t>
-            </a:r>
-            <a:endParaRPr lang="en-US" sz="1100" dirty="0"/>
-          </a:p>
-        </p:txBody>
-      </p:sp>
-      <p:sp>
-        <p:nvSpPr>
-          <p:cNvPr id="16" name="Arrow 5"/>
+              <a:t>Verifies</a:t>
+            </a:r>
+            <a:endParaRPr lang="en-US" sz="1400" dirty="0"/>
+          </a:p>
+        </p:txBody>
+      </p:sp>
+      <p:sp>
+        <p:nvSpPr>
+          <p:cNvPr id="15" name="Arrow 5"/>
           <p:cNvSpPr/>
           <p:nvPr/>
         </p:nvSpPr>
         <p:spPr>
           <a:xfrm>
-            <a:off x="9747504" y="2468880"/>
-            <a:ext cx="256032" cy="0"/>
+            <a:off x="9555480" y="2560320"/>
+            <a:ext cx="274320" cy="0"/>
           </a:xfrm>
           <a:prstGeom prst="line">
             <a:avLst/>
@@ -3425,14 +2980,14 @@
       </p:sp>
       <p:sp>
         <p:nvSpPr>
-          <p:cNvPr id="17" name="Deliver"/>
+          <p:cNvPr id="16" name="Deliver"/>
           <p:cNvSpPr txBox="1"/>
           <p:nvPr/>
         </p:nvSpPr>
         <p:spPr>
           <a:xfrm>
-            <a:off x="10003536" y="2011680"/>
-            <a:ext cx="1636776" cy="914400"/>
+            <a:off x="9829800" y="2103120"/>
+            <a:ext cx="1810512" cy="914400"/>
           </a:xfrm>
           <a:prstGeom prst="roundRect">
             <a:avLst>
@@ -3452,63 +3007,49 @@
               <a:buNone/>
             </a:pPr>
             <a:r>
-              <a:rPr lang="en-US" sz="1100" b="1" dirty="0">
+              <a:rPr lang="en-US" sz="1400" b="1" dirty="0">
                 <a:solidFill>
                   <a:schemeClr val="bg1"/>
                 </a:solidFill>
               </a:rPr>
-              <a:t>Results + drafts</a:t>
-            </a:r>
-            <a:endParaRPr lang="en-US" sz="1100" dirty="0"/>
-          </a:p>
-          <a:p>
-            <a:pPr algn="ctr" indent="0" marL="0">
-              <a:buNone/>
-            </a:pPr>
-            <a:r>
-              <a:rPr lang="en-US" sz="1100" b="1" dirty="0">
-                <a:solidFill>
-                  <a:schemeClr val="bg1"/>
-                </a:solidFill>
-              </a:rPr>
-              <a:t>saved on her PC</a:t>
-            </a:r>
-            <a:endParaRPr lang="en-US" sz="1100" dirty="0"/>
-          </a:p>
-        </p:txBody>
-      </p:sp>
-      <p:sp>
-        <p:nvSpPr>
-          <p:cNvPr id="18" name="Card 1"/>
+              <a:t>Saves results</a:t>
+            </a:r>
+            <a:endParaRPr lang="en-US" sz="1400" dirty="0"/>
+          </a:p>
+        </p:txBody>
+      </p:sp>
+      <p:sp>
+        <p:nvSpPr>
+          <p:cNvPr id="17" name="Legend 1 swatch"/>
           <p:cNvSpPr/>
           <p:nvPr/>
         </p:nvSpPr>
         <p:spPr>
           <a:xfrm>
             <a:off x="548640" y="4069080"/>
-            <a:ext cx="2606040" cy="1600200"/>
+            <a:ext cx="256032" cy="256032"/>
           </a:xfrm>
           <a:prstGeom prst="roundRect">
             <a:avLst>
-              <a:gd name="adj" fmla="val 4571"/>
+              <a:gd name="adj" fmla="val 17857"/>
             </a:avLst>
           </a:prstGeom>
           <a:solidFill>
-            <a:srgbClr val="1E293B"/>
-          </a:solidFill>
-          <a:ln/>
-        </p:spPr>
-      </p:sp>
-      <p:sp>
-        <p:nvSpPr>
-          <p:cNvPr id="19" name="Card 1 text"/>
+            <a:srgbClr val="1E40AF"/>
+          </a:solidFill>
+          <a:ln/>
+        </p:spPr>
+      </p:sp>
+      <p:sp>
+        <p:nvSpPr>
+          <p:cNvPr id="18" name="Legend 1"/>
           <p:cNvSpPr txBox="1"/>
           <p:nvPr/>
         </p:nvSpPr>
         <p:spPr>
           <a:xfrm>
-            <a:off x="731520" y="4206240"/>
-            <a:ext cx="2240280" cy="1371600"/>
+            <a:off x="914400" y="4050792"/>
+            <a:ext cx="2011680" cy="292608"/>
           </a:xfrm>
           <a:prstGeom prst="rect">
             <a:avLst/>
@@ -3517,76 +3058,56 @@
           <a:ln/>
         </p:spPr>
         <p:txBody>
-          <a:bodyPr wrap="square" lIns="0" tIns="0" rIns="0" bIns="0" rtlCol="0" anchor="t"/>
+          <a:bodyPr wrap="square" lIns="0" tIns="0" rIns="0" bIns="0" rtlCol="0" anchor="ctr"/>
           <a:lstStyle/>
           <a:p>
             <a:pPr indent="0" marL="0">
-              <a:spcAft>
-                <a:spcPts val="600"/>
-              </a:spcAft>
-              <a:buNone/>
-            </a:pPr>
-            <a:r>
-              <a:rPr lang="en-US" sz="1500" b="1" dirty="0">
-                <a:solidFill>
-                  <a:schemeClr val="accent1"/>
-                </a:solidFill>
-              </a:rPr>
-              <a:t>Automations</a:t>
-            </a:r>
-            <a:endParaRPr lang="en-US" sz="1600" dirty="0"/>
-          </a:p>
-          <a:p>
-            <a:pPr indent="0" marL="0">
-              <a:spcAft>
-                <a:spcPts val="600"/>
-              </a:spcAft>
               <a:buNone/>
             </a:pPr>
             <a:r>
               <a:rPr lang="en-US" sz="1300" dirty="0">
                 <a:solidFill>
-                  <a:schemeClr val="bg1"/>
-                </a:solidFill>
-              </a:rPr>
-              <a:t>A daily 8 am task looks for new jobs and tells her only what is new.</a:t>
-            </a:r>
-            <a:endParaRPr lang="en-US" sz="1600" dirty="0"/>
-          </a:p>
-        </p:txBody>
-      </p:sp>
-      <p:sp>
-        <p:nvSpPr>
-          <p:cNvPr id="20" name="Card 2"/>
+                  <a:schemeClr val="bg2"/>
+                </a:solidFill>
+              </a:rPr>
+              <a:t>WorkBuddy</a:t>
+            </a:r>
+            <a:endParaRPr lang="en-US" sz="1300" dirty="0"/>
+          </a:p>
+        </p:txBody>
+      </p:sp>
+      <p:sp>
+        <p:nvSpPr>
+          <p:cNvPr id="19" name="Legend 2 swatch"/>
           <p:cNvSpPr/>
           <p:nvPr/>
         </p:nvSpPr>
         <p:spPr>
           <a:xfrm>
-            <a:off x="3346704" y="4069080"/>
-            <a:ext cx="2606040" cy="1600200"/>
+            <a:off x="2926080" y="4069080"/>
+            <a:ext cx="256032" cy="256032"/>
           </a:xfrm>
           <a:prstGeom prst="roundRect">
             <a:avLst>
-              <a:gd name="adj" fmla="val 4571"/>
+              <a:gd name="adj" fmla="val 17857"/>
             </a:avLst>
           </a:prstGeom>
           <a:solidFill>
-            <a:srgbClr val="1E293B"/>
-          </a:solidFill>
-          <a:ln/>
-        </p:spPr>
-      </p:sp>
-      <p:sp>
-        <p:nvSpPr>
-          <p:cNvPr id="21" name="Card 2 text"/>
+            <a:srgbClr val="3B82F6"/>
+          </a:solidFill>
+          <a:ln/>
+        </p:spPr>
+      </p:sp>
+      <p:sp>
+        <p:nvSpPr>
+          <p:cNvPr id="20" name="Legend 2"/>
           <p:cNvSpPr txBox="1"/>
           <p:nvPr/>
         </p:nvSpPr>
         <p:spPr>
           <a:xfrm>
-            <a:off x="3529584" y="4206240"/>
-            <a:ext cx="2240280" cy="1371600"/>
+            <a:off x="3291840" y="4050792"/>
+            <a:ext cx="2011680" cy="292608"/>
           </a:xfrm>
           <a:prstGeom prst="rect">
             <a:avLst/>
@@ -3595,197 +3116,277 @@
           <a:ln/>
         </p:spPr>
         <p:txBody>
-          <a:bodyPr wrap="square" lIns="0" tIns="0" rIns="0" bIns="0" rtlCol="0" anchor="t"/>
+          <a:bodyPr wrap="square" lIns="0" tIns="0" rIns="0" bIns="0" rtlCol="0" anchor="ctr"/>
           <a:lstStyle/>
           <a:p>
             <a:pPr indent="0" marL="0">
-              <a:spcAft>
-                <a:spcPts val="600"/>
-              </a:spcAft>
-              <a:buNone/>
-            </a:pPr>
-            <a:r>
-              <a:rPr lang="en-US" sz="1500" b="1" dirty="0">
-                <a:solidFill>
-                  <a:schemeClr val="accent1"/>
-                </a:solidFill>
-              </a:rPr>
-              <a:t>Telegram channel</a:t>
-            </a:r>
-            <a:endParaRPr lang="en-US" sz="1600" dirty="0"/>
-          </a:p>
+              <a:buNone/>
+            </a:pPr>
+            <a:r>
+              <a:rPr lang="en-US" sz="1300" dirty="0">
+                <a:solidFill>
+                  <a:schemeClr val="bg2"/>
+                </a:solidFill>
+              </a:rPr>
+              <a:t>HireBuddy MCP tools</a:t>
+            </a:r>
+            <a:endParaRPr lang="en-US" sz="1300" dirty="0"/>
+          </a:p>
+        </p:txBody>
+      </p:sp>
+      <p:sp>
+        <p:nvSpPr>
+          <p:cNvPr id="21" name="Features label"/>
+          <p:cNvSpPr txBox="1"/>
+          <p:nvPr/>
+        </p:nvSpPr>
+        <p:spPr>
+          <a:xfrm>
+            <a:off x="548640" y="4800600"/>
+            <a:ext cx="5486400" cy="320040"/>
+          </a:xfrm>
+          <a:prstGeom prst="rect">
+            <a:avLst/>
+          </a:prstGeom>
+          <a:noFill/>
+          <a:ln/>
+        </p:spPr>
+        <p:txBody>
+          <a:bodyPr wrap="square" lIns="0" tIns="0" rIns="0" bIns="0" rtlCol="0" anchor="ctr"/>
+          <a:lstStyle/>
           <a:p>
             <a:pPr indent="0" marL="0">
-              <a:spcAft>
-                <a:spcPts val="600"/>
-              </a:spcAft>
               <a:buNone/>
             </a:pPr>
             <a:r>
               <a:rPr lang="en-US" sz="1300" dirty="0">
                 <a:solidFill>
-                  <a:schemeClr val="bg1"/>
-                </a:solidFill>
-              </a:rPr>
-              <a:t>She sends the sentence from her phone and gets a short, screen-reader-friendly reply.</a:t>
-            </a:r>
-            <a:endParaRPr lang="en-US" sz="1600" dirty="0"/>
-          </a:p>
-        </p:txBody>
-      </p:sp>
-      <p:sp>
-        <p:nvSpPr>
-          <p:cNvPr id="22" name="Card 3"/>
-          <p:cNvSpPr/>
-          <p:nvPr/>
-        </p:nvSpPr>
-        <p:spPr>
-          <a:xfrm>
-            <a:off x="6144768" y="4069080"/>
-            <a:ext cx="2606040" cy="1600200"/>
+                  <a:schemeClr val="bg2"/>
+                </a:solidFill>
+              </a:rPr>
+              <a:t>WorkBuddy features used</a:t>
+            </a:r>
+            <a:endParaRPr lang="en-US" sz="1300" dirty="0"/>
+          </a:p>
+        </p:txBody>
+      </p:sp>
+      <p:sp>
+        <p:nvSpPr>
+          <p:cNvPr id="22" name="Feature 1"/>
+          <p:cNvSpPr txBox="1"/>
+          <p:nvPr/>
+        </p:nvSpPr>
+        <p:spPr>
+          <a:xfrm>
+            <a:off x="548640" y="5212080"/>
+            <a:ext cx="2057400" cy="548640"/>
           </a:xfrm>
           <a:prstGeom prst="roundRect">
             <a:avLst>
-              <a:gd name="adj" fmla="val 4571"/>
+              <a:gd name="adj" fmla="val 13333"/>
             </a:avLst>
           </a:prstGeom>
           <a:solidFill>
             <a:srgbClr val="1E293B"/>
           </a:solidFill>
-          <a:ln/>
-        </p:spPr>
-      </p:sp>
-      <p:sp>
-        <p:nvSpPr>
-          <p:cNvPr id="23" name="Card 3 text"/>
+          <a:ln w="12700">
+            <a:solidFill>
+              <a:srgbClr val="1E40AF"/>
+            </a:solidFill>
+          </a:ln>
+        </p:spPr>
+        <p:txBody>
+          <a:bodyPr wrap="square" lIns="50800" tIns="50800" rIns="50800" bIns="50800" rtlCol="0" anchor="ctr"/>
+          <a:lstStyle/>
+          <a:p>
+            <a:pPr algn="ctr" indent="0" marL="0">
+              <a:buNone/>
+            </a:pPr>
+            <a:r>
+              <a:rPr lang="en-US" sz="1500" b="1" dirty="0">
+                <a:solidFill>
+                  <a:schemeClr val="bg1"/>
+                </a:solidFill>
+              </a:rPr>
+              <a:t>Local files</a:t>
+            </a:r>
+            <a:endParaRPr lang="en-US" sz="1500" dirty="0"/>
+          </a:p>
+        </p:txBody>
+      </p:sp>
+      <p:sp>
+        <p:nvSpPr>
+          <p:cNvPr id="23" name="Feature 2"/>
           <p:cNvSpPr txBox="1"/>
           <p:nvPr/>
         </p:nvSpPr>
         <p:spPr>
           <a:xfrm>
-            <a:off x="6327648" y="4206240"/>
-            <a:ext cx="2240280" cy="1371600"/>
-          </a:xfrm>
-          <a:prstGeom prst="rect">
-            <a:avLst/>
-          </a:prstGeom>
-          <a:noFill/>
-          <a:ln/>
-        </p:spPr>
-        <p:txBody>
-          <a:bodyPr wrap="square" lIns="0" tIns="0" rIns="0" bIns="0" rtlCol="0" anchor="t"/>
-          <a:lstStyle/>
-          <a:p>
-            <a:pPr indent="0" marL="0">
-              <a:spcAft>
-                <a:spcPts val="600"/>
-              </a:spcAft>
-              <a:buNone/>
-            </a:pPr>
-            <a:r>
-              <a:rPr lang="en-US" sz="1500" b="1" dirty="0">
-                <a:solidFill>
-                  <a:schemeClr val="accent1"/>
-                </a:solidFill>
-              </a:rPr>
-              <a:t>Connected email</a:t>
-            </a:r>
-            <a:endParaRPr lang="en-US" sz="1600" dirty="0"/>
-          </a:p>
-          <a:p>
-            <a:pPr indent="0" marL="0">
-              <a:spcAft>
-                <a:spcPts val="600"/>
-              </a:spcAft>
-              <a:buNone/>
-            </a:pPr>
-            <a:r>
-              <a:rPr lang="en-US" sz="1300" dirty="0">
-                <a:solidFill>
-                  <a:schemeClr val="bg1"/>
-                </a:solidFill>
-              </a:rPr>
-              <a:t>After she selects a job, WorkBuddy sends the application from her own account.</a:t>
-            </a:r>
-            <a:endParaRPr lang="en-US" sz="1600" dirty="0"/>
-          </a:p>
-        </p:txBody>
-      </p:sp>
-      <p:sp>
-        <p:nvSpPr>
-          <p:cNvPr id="24" name="Card 4"/>
-          <p:cNvSpPr/>
-          <p:nvPr/>
-        </p:nvSpPr>
-        <p:spPr>
-          <a:xfrm>
-            <a:off x="8942832" y="4069080"/>
-            <a:ext cx="2606040" cy="1600200"/>
+            <a:off x="2788920" y="5212080"/>
+            <a:ext cx="2057400" cy="548640"/>
           </a:xfrm>
           <a:prstGeom prst="roundRect">
             <a:avLst>
-              <a:gd name="adj" fmla="val 4571"/>
+              <a:gd name="adj" fmla="val 13333"/>
             </a:avLst>
           </a:prstGeom>
           <a:solidFill>
             <a:srgbClr val="1E293B"/>
           </a:solidFill>
-          <a:ln/>
-        </p:spPr>
-      </p:sp>
-      <p:sp>
-        <p:nvSpPr>
-          <p:cNvPr id="25" name="Card 4 text"/>
+          <a:ln w="12700">
+            <a:solidFill>
+              <a:srgbClr val="1E40AF"/>
+            </a:solidFill>
+          </a:ln>
+        </p:spPr>
+        <p:txBody>
+          <a:bodyPr wrap="square" lIns="50800" tIns="50800" rIns="50800" bIns="50800" rtlCol="0" anchor="ctr"/>
+          <a:lstStyle/>
+          <a:p>
+            <a:pPr algn="ctr" indent="0" marL="0">
+              <a:buNone/>
+            </a:pPr>
+            <a:r>
+              <a:rPr lang="en-US" sz="1500" b="1" dirty="0">
+                <a:solidFill>
+                  <a:schemeClr val="bg1"/>
+                </a:solidFill>
+              </a:rPr>
+              <a:t>Web search</a:t>
+            </a:r>
+            <a:endParaRPr lang="en-US" sz="1500" dirty="0"/>
+          </a:p>
+        </p:txBody>
+      </p:sp>
+      <p:sp>
+        <p:nvSpPr>
+          <p:cNvPr id="24" name="Feature 3"/>
           <p:cNvSpPr txBox="1"/>
           <p:nvPr/>
         </p:nvSpPr>
         <p:spPr>
           <a:xfrm>
-            <a:off x="9125712" y="4206240"/>
-            <a:ext cx="2240280" cy="1371600"/>
-          </a:xfrm>
-          <a:prstGeom prst="rect">
-            <a:avLst/>
-          </a:prstGeom>
-          <a:noFill/>
-          <a:ln/>
-        </p:spPr>
-        <p:txBody>
-          <a:bodyPr wrap="square" lIns="0" tIns="0" rIns="0" bIns="0" rtlCol="0" anchor="t"/>
-          <a:lstStyle/>
-          <a:p>
-            <a:pPr indent="0" marL="0">
-              <a:spcAft>
-                <a:spcPts val="600"/>
-              </a:spcAft>
+            <a:off x="5029200" y="5212080"/>
+            <a:ext cx="2057400" cy="548640"/>
+          </a:xfrm>
+          <a:prstGeom prst="roundRect">
+            <a:avLst>
+              <a:gd name="adj" fmla="val 13333"/>
+            </a:avLst>
+          </a:prstGeom>
+          <a:solidFill>
+            <a:srgbClr val="1E293B"/>
+          </a:solidFill>
+          <a:ln w="12700">
+            <a:solidFill>
+              <a:srgbClr val="1E40AF"/>
+            </a:solidFill>
+          </a:ln>
+        </p:spPr>
+        <p:txBody>
+          <a:bodyPr wrap="square" lIns="50800" tIns="50800" rIns="50800" bIns="50800" rtlCol="0" anchor="ctr"/>
+          <a:lstStyle/>
+          <a:p>
+            <a:pPr algn="ctr" indent="0" marL="0">
               <a:buNone/>
             </a:pPr>
             <a:r>
               <a:rPr lang="en-US" sz="1500" b="1" dirty="0">
                 <a:solidFill>
-                  <a:schemeClr val="accent1"/>
-                </a:solidFill>
-              </a:rPr>
-              <a:t>Fallback</a:t>
-            </a:r>
-            <a:endParaRPr lang="en-US" sz="1600" dirty="0"/>
-          </a:p>
-          <a:p>
-            <a:pPr indent="0" marL="0">
-              <a:spcAft>
-                <a:spcPts val="600"/>
-              </a:spcAft>
-              <a:buNone/>
-            </a:pPr>
-            <a:r>
-              <a:rPr lang="en-US" sz="1300" dirty="0">
-                <a:solidFill>
                   <a:schemeClr val="bg1"/>
                 </a:solidFill>
               </a:rPr>
-              <a:t>If a step tool fails, hirebuddy_run does the whole job in one call.</a:t>
-            </a:r>
-            <a:endParaRPr lang="en-US" sz="1600" dirty="0"/>
+              <a:t>Automations</a:t>
+            </a:r>
+            <a:endParaRPr lang="en-US" sz="1500" dirty="0"/>
+          </a:p>
+        </p:txBody>
+      </p:sp>
+      <p:sp>
+        <p:nvSpPr>
+          <p:cNvPr id="25" name="Feature 4"/>
+          <p:cNvSpPr txBox="1"/>
+          <p:nvPr/>
+        </p:nvSpPr>
+        <p:spPr>
+          <a:xfrm>
+            <a:off x="7269480" y="5212080"/>
+            <a:ext cx="2057400" cy="548640"/>
+          </a:xfrm>
+          <a:prstGeom prst="roundRect">
+            <a:avLst>
+              <a:gd name="adj" fmla="val 13333"/>
+            </a:avLst>
+          </a:prstGeom>
+          <a:solidFill>
+            <a:srgbClr val="1E293B"/>
+          </a:solidFill>
+          <a:ln w="12700">
+            <a:solidFill>
+              <a:srgbClr val="1E40AF"/>
+            </a:solidFill>
+          </a:ln>
+        </p:spPr>
+        <p:txBody>
+          <a:bodyPr wrap="square" lIns="50800" tIns="50800" rIns="50800" bIns="50800" rtlCol="0" anchor="ctr"/>
+          <a:lstStyle/>
+          <a:p>
+            <a:pPr algn="ctr" indent="0" marL="0">
+              <a:buNone/>
+            </a:pPr>
+            <a:r>
+              <a:rPr lang="en-US" sz="1500" b="1" dirty="0">
+                <a:solidFill>
+                  <a:schemeClr val="bg1"/>
+                </a:solidFill>
+              </a:rPr>
+              <a:t>Telegram</a:t>
+            </a:r>
+            <a:endParaRPr lang="en-US" sz="1500" dirty="0"/>
+          </a:p>
+        </p:txBody>
+      </p:sp>
+      <p:sp>
+        <p:nvSpPr>
+          <p:cNvPr id="26" name="Feature 5"/>
+          <p:cNvSpPr txBox="1"/>
+          <p:nvPr/>
+        </p:nvSpPr>
+        <p:spPr>
+          <a:xfrm>
+            <a:off x="9509760" y="5212080"/>
+            <a:ext cx="2057400" cy="548640"/>
+          </a:xfrm>
+          <a:prstGeom prst="roundRect">
+            <a:avLst>
+              <a:gd name="adj" fmla="val 13333"/>
+            </a:avLst>
+          </a:prstGeom>
+          <a:solidFill>
+            <a:srgbClr val="1E293B"/>
+          </a:solidFill>
+          <a:ln w="12700">
+            <a:solidFill>
+              <a:srgbClr val="1E40AF"/>
+            </a:solidFill>
+          </a:ln>
+        </p:spPr>
+        <p:txBody>
+          <a:bodyPr wrap="square" lIns="50800" tIns="50800" rIns="50800" bIns="50800" rtlCol="0" anchor="ctr"/>
+          <a:lstStyle/>
+          <a:p>
+            <a:pPr algn="ctr" indent="0" marL="0">
+              <a:buNone/>
+            </a:pPr>
+            <a:r>
+              <a:rPr lang="en-US" sz="1500" b="1" dirty="0">
+                <a:solidFill>
+                  <a:schemeClr val="bg1"/>
+                </a:solidFill>
+              </a:rPr>
+              <a:t>Email</a:t>
+            </a:r>
+            <a:endParaRPr lang="en-US" sz="1500" dirty="0"/>
           </a:p>
         </p:txBody>
       </p:sp>
@@ -3899,14 +3500,34 @@
       </p:sp>
       <p:sp>
         <p:nvSpPr>
-          <p:cNvPr id="3" name="Trace label"/>
+          <p:cNvPr id="3" name="Step 1 marker"/>
+          <p:cNvSpPr/>
+          <p:nvPr/>
+        </p:nvSpPr>
+        <p:spPr>
+          <a:xfrm>
+            <a:off x="548640" y="1664208"/>
+            <a:ext cx="329184" cy="329184"/>
+          </a:xfrm>
+          <a:prstGeom prst="ellipse">
+            <a:avLst/>
+          </a:prstGeom>
+          <a:solidFill>
+            <a:srgbClr val="F59E0B"/>
+          </a:solidFill>
+          <a:ln/>
+        </p:spPr>
+      </p:sp>
+      <p:sp>
+        <p:nvSpPr>
+          <p:cNvPr id="4" name="Step 1"/>
           <p:cNvSpPr txBox="1"/>
           <p:nvPr/>
         </p:nvSpPr>
         <p:spPr>
           <a:xfrm>
-            <a:off x="548640" y="1143000"/>
-            <a:ext cx="5120640" cy="365760"/>
+            <a:off x="1051560" y="1600200"/>
+            <a:ext cx="4572000" cy="457200"/>
           </a:xfrm>
           <a:prstGeom prst="rect">
             <a:avLst/>
@@ -3922,47 +3543,47 @@
               <a:buNone/>
             </a:pPr>
             <a:r>
-              <a:rPr lang="en-US" sz="1400" dirty="0">
-                <a:solidFill>
-                  <a:schemeClr val="bg2"/>
-                </a:solidFill>
-              </a:rPr>
-              <a:t>From a real run on Nadia's sentence</a:t>
-            </a:r>
-            <a:endParaRPr lang="en-US" sz="1400" dirty="0"/>
-          </a:p>
-        </p:txBody>
-      </p:sp>
-      <p:sp>
-        <p:nvSpPr>
-          <p:cNvPr id="4" name="Step 1 marker"/>
+              <a:rPr lang="en-US" sz="1800" b="1" dirty="0">
+                <a:solidFill>
+                  <a:schemeClr val="bg1"/>
+                </a:solidFill>
+              </a:rPr>
+              <a:t>Only 2 of 3 jobs fit</a:t>
+            </a:r>
+            <a:endParaRPr lang="en-US" sz="1800" dirty="0"/>
+          </a:p>
+        </p:txBody>
+      </p:sp>
+      <p:sp>
+        <p:nvSpPr>
+          <p:cNvPr id="5" name="Step 2 marker"/>
           <p:cNvSpPr/>
           <p:nvPr/>
         </p:nvSpPr>
         <p:spPr>
           <a:xfrm>
-            <a:off x="548640" y="1691640"/>
+            <a:off x="548640" y="2624328"/>
             <a:ext cx="329184" cy="329184"/>
           </a:xfrm>
           <a:prstGeom prst="ellipse">
             <a:avLst/>
           </a:prstGeom>
           <a:solidFill>
-            <a:srgbClr val="F59E0B"/>
-          </a:solidFill>
-          <a:ln/>
-        </p:spPr>
-      </p:sp>
-      <p:sp>
-        <p:nvSpPr>
-          <p:cNvPr id="5" name="Step 1"/>
+            <a:srgbClr val="3B82F6"/>
+          </a:solidFill>
+          <a:ln/>
+        </p:spPr>
+      </p:sp>
+      <p:sp>
+        <p:nvSpPr>
+          <p:cNvPr id="6" name="Step 2"/>
           <p:cNvSpPr txBox="1"/>
           <p:nvPr/>
         </p:nvSpPr>
         <p:spPr>
           <a:xfrm>
-            <a:off x="1051560" y="1645920"/>
-            <a:ext cx="4572000" cy="960120"/>
+            <a:off x="1051560" y="2560320"/>
+            <a:ext cx="4572000" cy="457200"/>
           </a:xfrm>
           <a:prstGeom prst="rect">
             <a:avLst/>
@@ -3971,68 +3592,110 @@
           <a:ln/>
         </p:spPr>
         <p:txBody>
-          <a:bodyPr wrap="square" lIns="0" tIns="0" rIns="0" bIns="0" rtlCol="0" anchor="t"/>
+          <a:bodyPr wrap="square" lIns="0" tIns="0" rIns="0" bIns="0" rtlCol="0" anchor="ctr"/>
           <a:lstStyle/>
           <a:p>
             <a:pPr indent="0" marL="0">
               <a:buNone/>
             </a:pPr>
             <a:r>
-              <a:rPr lang="en-US" sz="1500" b="1" dirty="0">
+              <a:rPr lang="en-US" sz="1800" b="1" dirty="0">
                 <a:solidFill>
                   <a:schemeClr val="bg1"/>
                 </a:solidFill>
               </a:rPr>
-              <a:t>Round 1</a:t>
-            </a:r>
-            <a:endParaRPr lang="en-US" sz="1500" dirty="0"/>
-          </a:p>
+              <a:t>Tests 5 ways to widen</a:t>
+            </a:r>
+            <a:endParaRPr lang="en-US" sz="1800" dirty="0"/>
+          </a:p>
+        </p:txBody>
+      </p:sp>
+      <p:sp>
+        <p:nvSpPr>
+          <p:cNvPr id="7" name="Step 3 marker"/>
+          <p:cNvSpPr/>
+          <p:nvPr/>
+        </p:nvSpPr>
+        <p:spPr>
+          <a:xfrm>
+            <a:off x="548640" y="3584448"/>
+            <a:ext cx="329184" cy="329184"/>
+          </a:xfrm>
+          <a:prstGeom prst="ellipse">
+            <a:avLst/>
+          </a:prstGeom>
+          <a:solidFill>
+            <a:srgbClr val="10B981"/>
+          </a:solidFill>
+          <a:ln/>
+        </p:spPr>
+      </p:sp>
+      <p:sp>
+        <p:nvSpPr>
+          <p:cNvPr id="8" name="Step 3"/>
+          <p:cNvSpPr txBox="1"/>
+          <p:nvPr/>
+        </p:nvSpPr>
+        <p:spPr>
+          <a:xfrm>
+            <a:off x="1051560" y="3520440"/>
+            <a:ext cx="4572000" cy="457200"/>
+          </a:xfrm>
+          <a:prstGeom prst="rect">
+            <a:avLst/>
+          </a:prstGeom>
+          <a:noFill/>
+          <a:ln/>
+        </p:spPr>
+        <p:txBody>
+          <a:bodyPr wrap="square" lIns="0" tIns="0" rIns="0" bIns="0" rtlCol="0" anchor="ctr"/>
+          <a:lstStyle/>
           <a:p>
             <a:pPr indent="0" marL="0">
               <a:buNone/>
             </a:pPr>
             <a:r>
-              <a:rPr lang="en-US" sz="1300" dirty="0">
-                <a:solidFill>
-                  <a:schemeClr val="bg2"/>
-                </a:solidFill>
-              </a:rPr>
-              <a:t>Only 2 of 3 jobs fit. Not good enough yet.</a:t>
-            </a:r>
-            <a:endParaRPr lang="en-US" sz="1500" dirty="0"/>
-          </a:p>
-        </p:txBody>
-      </p:sp>
-      <p:sp>
-        <p:nvSpPr>
-          <p:cNvPr id="6" name="Step 2 marker"/>
+              <a:rPr lang="en-US" sz="1800" b="1" dirty="0">
+                <a:solidFill>
+                  <a:schemeClr val="bg1"/>
+                </a:solidFill>
+              </a:rPr>
+              <a:t>None helps: stops, no padding</a:t>
+            </a:r>
+            <a:endParaRPr lang="en-US" sz="1800" dirty="0"/>
+          </a:p>
+        </p:txBody>
+      </p:sp>
+      <p:sp>
+        <p:nvSpPr>
+          <p:cNvPr id="9" name="Step 4 marker"/>
           <p:cNvSpPr/>
           <p:nvPr/>
         </p:nvSpPr>
         <p:spPr>
           <a:xfrm>
-            <a:off x="548640" y="2770632"/>
+            <a:off x="548640" y="4544568"/>
             <a:ext cx="329184" cy="329184"/>
           </a:xfrm>
           <a:prstGeom prst="ellipse">
             <a:avLst/>
           </a:prstGeom>
           <a:solidFill>
-            <a:srgbClr val="3B82F6"/>
-          </a:solidFill>
-          <a:ln/>
-        </p:spPr>
-      </p:sp>
-      <p:sp>
-        <p:nvSpPr>
-          <p:cNvPr id="7" name="Step 2"/>
+            <a:srgbClr val="EF4444"/>
+          </a:solidFill>
+          <a:ln/>
+        </p:spPr>
+      </p:sp>
+      <p:sp>
+        <p:nvSpPr>
+          <p:cNvPr id="10" name="Step 4"/>
           <p:cNvSpPr txBox="1"/>
           <p:nvPr/>
         </p:nvSpPr>
         <p:spPr>
           <a:xfrm>
-            <a:off x="1051560" y="2724912"/>
-            <a:ext cx="4572000" cy="960120"/>
+            <a:off x="1051560" y="4480560"/>
+            <a:ext cx="4572000" cy="457200"/>
           </a:xfrm>
           <a:prstGeom prst="rect">
             <a:avLst/>
@@ -4041,181 +3704,27 @@
           <a:ln/>
         </p:spPr>
         <p:txBody>
-          <a:bodyPr wrap="square" lIns="0" tIns="0" rIns="0" bIns="0" rtlCol="0" anchor="t"/>
+          <a:bodyPr wrap="square" lIns="0" tIns="0" rIns="0" bIns="0" rtlCol="0" anchor="ctr"/>
           <a:lstStyle/>
           <a:p>
             <a:pPr indent="0" marL="0">
               <a:buNone/>
             </a:pPr>
             <a:r>
-              <a:rPr lang="en-US" sz="1500" b="1" dirty="0">
+              <a:rPr lang="en-US" sz="1800" b="1" dirty="0">
                 <a:solidFill>
                   <a:schemeClr val="bg1"/>
                 </a:solidFill>
               </a:rPr>
-              <a:t>Tests 5 ways to widen</a:t>
-            </a:r>
-            <a:endParaRPr lang="en-US" sz="1500" dirty="0"/>
-          </a:p>
-          <a:p>
-            <a:pPr indent="0" marL="0">
-              <a:buNone/>
-            </a:pPr>
-            <a:r>
-              <a:rPr lang="en-US" sz="1300" dirty="0">
-                <a:solidFill>
-                  <a:schemeClr val="bg2"/>
-                </a:solidFill>
-              </a:rPr>
-              <a:t>Wider area, longer walk, ask about screen readers, lower pay. Each one simulated first.</a:t>
-            </a:r>
-            <a:endParaRPr lang="en-US" sz="1500" dirty="0"/>
-          </a:p>
-        </p:txBody>
-      </p:sp>
-      <p:sp>
-        <p:nvSpPr>
-          <p:cNvPr id="8" name="Step 3 marker"/>
-          <p:cNvSpPr/>
-          <p:nvPr/>
-        </p:nvSpPr>
-        <p:spPr>
-          <a:xfrm>
-            <a:off x="548640" y="3849624"/>
-            <a:ext cx="329184" cy="329184"/>
-          </a:xfrm>
-          <a:prstGeom prst="ellipse">
-            <a:avLst/>
-          </a:prstGeom>
-          <a:solidFill>
-            <a:srgbClr val="10B981"/>
-          </a:solidFill>
-          <a:ln/>
-        </p:spPr>
-      </p:sp>
-      <p:sp>
-        <p:nvSpPr>
-          <p:cNvPr id="9" name="Step 3"/>
-          <p:cNvSpPr txBox="1"/>
-          <p:nvPr/>
-        </p:nvSpPr>
-        <p:spPr>
-          <a:xfrm>
-            <a:off x="1051560" y="3803904"/>
-            <a:ext cx="4572000" cy="960120"/>
-          </a:xfrm>
-          <a:prstGeom prst="rect">
-            <a:avLst/>
-          </a:prstGeom>
-          <a:noFill/>
-          <a:ln/>
-        </p:spPr>
-        <p:txBody>
-          <a:bodyPr wrap="square" lIns="0" tIns="0" rIns="0" bIns="0" rtlCol="0" anchor="t"/>
-          <a:lstStyle/>
-          <a:p>
-            <a:pPr indent="0" marL="0">
-              <a:buNone/>
-            </a:pPr>
-            <a:r>
-              <a:rPr lang="en-US" sz="1500" b="1" dirty="0">
-                <a:solidFill>
-                  <a:schemeClr val="bg1"/>
-                </a:solidFill>
-              </a:rPr>
-              <a:t>Chooses to stop</a:t>
-            </a:r>
-            <a:endParaRPr lang="en-US" sz="1500" dirty="0"/>
-          </a:p>
-          <a:p>
-            <a:pPr indent="0" marL="0">
-              <a:buNone/>
-            </a:pPr>
-            <a:r>
-              <a:rPr lang="en-US" sz="1300" dirty="0">
-                <a:solidFill>
-                  <a:schemeClr val="bg2"/>
-                </a:solidFill>
-              </a:rPr>
-              <a:t>None adds a job that suits her, so it says what came closest instead of padding the list.</a:t>
-            </a:r>
-            <a:endParaRPr lang="en-US" sz="1500" dirty="0"/>
-          </a:p>
-        </p:txBody>
-      </p:sp>
-      <p:sp>
-        <p:nvSpPr>
-          <p:cNvPr id="10" name="Step 4 marker"/>
-          <p:cNvSpPr/>
-          <p:nvPr/>
-        </p:nvSpPr>
-        <p:spPr>
-          <a:xfrm>
-            <a:off x="548640" y="4928616"/>
-            <a:ext cx="329184" cy="329184"/>
-          </a:xfrm>
-          <a:prstGeom prst="ellipse">
-            <a:avLst/>
-          </a:prstGeom>
-          <a:solidFill>
-            <a:srgbClr val="EF4444"/>
-          </a:solidFill>
-          <a:ln/>
-        </p:spPr>
-      </p:sp>
-      <p:sp>
-        <p:nvSpPr>
-          <p:cNvPr id="11" name="Step 4"/>
-          <p:cNvSpPr txBox="1"/>
-          <p:nvPr/>
-        </p:nvSpPr>
-        <p:spPr>
-          <a:xfrm>
-            <a:off x="1051560" y="4882896"/>
-            <a:ext cx="4572000" cy="960120"/>
-          </a:xfrm>
-          <a:prstGeom prst="rect">
-            <a:avLst/>
-          </a:prstGeom>
-          <a:noFill/>
-          <a:ln/>
-        </p:spPr>
-        <p:txBody>
-          <a:bodyPr wrap="square" lIns="0" tIns="0" rIns="0" bIns="0" rtlCol="0" anchor="t"/>
-          <a:lstStyle/>
-          <a:p>
-            <a:pPr indent="0" marL="0">
-              <a:buNone/>
-            </a:pPr>
-            <a:r>
-              <a:rPr lang="en-US" sz="1500" b="1" dirty="0">
-                <a:solidFill>
-                  <a:schemeClr val="bg1"/>
-                </a:solidFill>
-              </a:rPr>
-              <a:t>Won't do alone</a:t>
-            </a:r>
-            <a:endParaRPr lang="en-US" sz="1500" dirty="0"/>
-          </a:p>
-          <a:p>
-            <a:pPr indent="0" marL="0">
-              <a:buNone/>
-            </a:pPr>
-            <a:r>
-              <a:rPr lang="en-US" sz="1300" dirty="0">
-                <a:solidFill>
-                  <a:schemeClr val="bg2"/>
-                </a:solidFill>
-              </a:rPr>
-              <a:t>Lowering her RM12 floor needs her OK.</a:t>
-            </a:r>
-            <a:endParaRPr lang="en-US" sz="1500" dirty="0"/>
-          </a:p>
-        </p:txBody>
-      </p:sp>
-      <p:sp>
-        <p:nvSpPr>
-          <p:cNvPr id="12" name="Loop Goal"/>
+              <a:t>Lower her pay? Asks first</a:t>
+            </a:r>
+            <a:endParaRPr lang="en-US" sz="1800" dirty="0"/>
+          </a:p>
+        </p:txBody>
+      </p:sp>
+      <p:sp>
+        <p:nvSpPr>
+          <p:cNvPr id="11" name="Loop Goal"/>
           <p:cNvSpPr txBox="1"/>
           <p:nvPr/>
         </p:nvSpPr>
@@ -4255,7 +3764,7 @@
       </p:sp>
       <p:sp>
         <p:nvSpPr>
-          <p:cNvPr id="13" name="Loop arrow 1"/>
+          <p:cNvPr id="12" name="Loop arrow 1"/>
           <p:cNvSpPr/>
           <p:nvPr/>
         </p:nvSpPr>
@@ -4279,7 +3788,7 @@
       </p:sp>
       <p:sp>
         <p:nvSpPr>
-          <p:cNvPr id="14" name="Loop Plan"/>
+          <p:cNvPr id="13" name="Loop Plan"/>
           <p:cNvSpPr txBox="1"/>
           <p:nvPr/>
         </p:nvSpPr>
@@ -4319,7 +3828,7 @@
       </p:sp>
       <p:sp>
         <p:nvSpPr>
-          <p:cNvPr id="15" name="Loop arrow 2"/>
+          <p:cNvPr id="14" name="Loop arrow 2"/>
           <p:cNvSpPr/>
           <p:nvPr/>
         </p:nvSpPr>
@@ -4343,7 +3852,7 @@
       </p:sp>
       <p:sp>
         <p:nvSpPr>
-          <p:cNvPr id="16" name="Loop Tools"/>
+          <p:cNvPr id="15" name="Loop Tools"/>
           <p:cNvSpPr txBox="1"/>
           <p:nvPr/>
         </p:nvSpPr>
@@ -4383,7 +3892,7 @@
       </p:sp>
       <p:sp>
         <p:nvSpPr>
-          <p:cNvPr id="17" name="Loop arrow 3"/>
+          <p:cNvPr id="16" name="Loop arrow 3"/>
           <p:cNvSpPr/>
           <p:nvPr/>
         </p:nvSpPr>
@@ -4407,7 +3916,7 @@
       </p:sp>
       <p:sp>
         <p:nvSpPr>
-          <p:cNvPr id="18" name="Loop Verify"/>
+          <p:cNvPr id="17" name="Loop Verify"/>
           <p:cNvSpPr txBox="1"/>
           <p:nvPr/>
         </p:nvSpPr>
@@ -4447,7 +3956,7 @@
       </p:sp>
       <p:sp>
         <p:nvSpPr>
-          <p:cNvPr id="19" name="Loop arrow 4"/>
+          <p:cNvPr id="18" name="Loop arrow 4"/>
           <p:cNvSpPr/>
           <p:nvPr/>
         </p:nvSpPr>
@@ -4471,7 +3980,7 @@
       </p:sp>
       <p:sp>
         <p:nvSpPr>
-          <p:cNvPr id="20" name="Loop Deliver"/>
+          <p:cNvPr id="19" name="Loop Deliver"/>
           <p:cNvSpPr txBox="1"/>
           <p:nvPr/>
         </p:nvSpPr>
@@ -4511,7 +4020,7 @@
       </p:sp>
       <p:sp>
         <p:nvSpPr>
-          <p:cNvPr id="21" name="Loop Fix"/>
+          <p:cNvPr id="20" name="Loop Fix"/>
           <p:cNvSpPr txBox="1"/>
           <p:nvPr/>
         </p:nvSpPr>
@@ -4551,7 +4060,7 @@
       </p:sp>
       <p:sp>
         <p:nvSpPr>
-          <p:cNvPr id="22" name="Problems arrow"/>
+          <p:cNvPr id="21" name="Problems arrow"/>
           <p:cNvSpPr/>
           <p:nvPr/>
         </p:nvSpPr>
@@ -4575,7 +4084,7 @@
       </p:sp>
       <p:sp>
         <p:nvSpPr>
-          <p:cNvPr id="23" name="Retry arrow"/>
+          <p:cNvPr id="22" name="Retry arrow"/>
           <p:cNvSpPr/>
           <p:nvPr/>
         </p:nvSpPr>
@@ -4599,7 +4108,7 @@
       </p:sp>
       <p:sp>
         <p:nvSpPr>
-          <p:cNvPr id="24" name="Problems label"/>
+          <p:cNvPr id="23" name="Problems label"/>
           <p:cNvSpPr txBox="1"/>
           <p:nvPr/>
         </p:nvSpPr>
@@ -4635,7 +4144,7 @@
       </p:sp>
       <p:sp>
         <p:nvSpPr>
-          <p:cNvPr id="25" name="Retry label"/>
+          <p:cNvPr id="24" name="Retry label"/>
           <p:cNvSpPr txBox="1"/>
           <p:nvPr/>
         </p:nvSpPr>
@@ -4671,14 +4180,14 @@
       </p:sp>
       <p:sp>
         <p:nvSpPr>
-          <p:cNvPr id="26" name="Loop notes"/>
+          <p:cNvPr id="25" name="Loop note"/>
           <p:cNvSpPr txBox="1"/>
           <p:nvPr/>
         </p:nvSpPr>
         <p:spPr>
           <a:xfrm>
-            <a:off x="6172200" y="4434840"/>
-            <a:ext cx="5257800" cy="1280160"/>
+            <a:off x="6172200" y="4480560"/>
+            <a:ext cx="5257800" cy="457200"/>
           </a:xfrm>
           <a:prstGeom prst="rect">
             <a:avLst/>
@@ -4687,58 +4196,21 @@
           <a:ln/>
         </p:spPr>
         <p:txBody>
-          <a:bodyPr wrap="square" lIns="0" tIns="0" rIns="0" bIns="0" rtlCol="0" anchor="t"/>
+          <a:bodyPr wrap="square" lIns="0" tIns="0" rIns="0" bIns="0" rtlCol="0" anchor="ctr"/>
           <a:lstStyle/>
           <a:p>
             <a:pPr indent="0" marL="0">
-              <a:spcAft>
-                <a:spcPts val="800"/>
-              </a:spcAft>
-              <a:buNone/>
-            </a:pPr>
-            <a:r>
-              <a:rPr lang="en-US" sz="1400" dirty="0">
-                <a:solidFill>
-                  <a:schemeClr val="bg2"/>
-                </a:solidFill>
-              </a:rPr>
-              <a:t>Every tool returns a result or a list of specific problems.</a:t>
-            </a:r>
-            <a:endParaRPr lang="en-US" sz="1400" dirty="0"/>
-          </a:p>
-          <a:p>
-            <a:pPr indent="0" marL="0">
-              <a:spcAft>
-                <a:spcPts val="800"/>
-              </a:spcAft>
-              <a:buNone/>
-            </a:pPr>
-            <a:r>
-              <a:rPr lang="en-US" sz="1400" dirty="0">
-                <a:solidFill>
-                  <a:schemeClr val="bg2"/>
-                </a:solidFill>
-              </a:rPr>
-              <a:t>LLM or rule-based planner, same checks.</a:t>
-            </a:r>
-            <a:endParaRPr lang="en-US" sz="1400" dirty="0"/>
-          </a:p>
-          <a:p>
-            <a:pPr indent="0" marL="0">
-              <a:spcAft>
-                <a:spcPts val="800"/>
-              </a:spcAft>
-              <a:buNone/>
-            </a:pPr>
-            <a:r>
-              <a:rPr lang="en-US" sz="1400" b="1" dirty="0">
+              <a:buNone/>
+            </a:pPr>
+            <a:r>
+              <a:rPr lang="en-US" sz="1800" b="1" dirty="0">
                 <a:solidFill>
                   <a:schemeClr val="accent1"/>
                 </a:solidFill>
               </a:rPr>
-              <a:t>The run cannot finish until verification passes.</a:t>
-            </a:r>
-            <a:endParaRPr lang="en-US" sz="1400" dirty="0"/>
+              <a:t>Can't finish until verified.</a:t>
+            </a:r>
+            <a:endParaRPr lang="en-US" sz="1800" dirty="0"/>
           </a:p>
         </p:txBody>
       </p:sp>
@@ -4876,43 +4348,7 @@
       </p:pic>
       <p:sp>
         <p:nvSpPr>
-          <p:cNvPr id="4" name="Screenshot caption"/>
-          <p:cNvSpPr txBox="1"/>
-          <p:nvPr/>
-        </p:nvSpPr>
-        <p:spPr>
-          <a:xfrm>
-            <a:off x="548640" y="6035040"/>
-            <a:ext cx="3831336" cy="274320"/>
-          </a:xfrm>
-          <a:prstGeom prst="rect">
-            <a:avLst/>
-          </a:prstGeom>
-          <a:noFill/>
-          <a:ln/>
-        </p:spPr>
-        <p:txBody>
-          <a:bodyPr wrap="square" lIns="0" tIns="0" rIns="0" bIns="0" rtlCol="0" anchor="ctr"/>
-          <a:lstStyle/>
-          <a:p>
-            <a:pPr algn="ctr" indent="0" marL="0">
-              <a:buNone/>
-            </a:pPr>
-            <a:r>
-              <a:rPr lang="en-US" sz="1100" dirty="0">
-                <a:solidFill>
-                  <a:schemeClr val="bg2"/>
-                </a:solidFill>
-              </a:rPr>
-              <a:t>Result page for the slide 2 sentence</a:t>
-            </a:r>
-            <a:endParaRPr lang="en-US" sz="1100" dirty="0"/>
-          </a:p>
-        </p:txBody>
-      </p:sp>
-      <p:sp>
-        <p:nvSpPr>
-          <p:cNvPr id="5" name="Stat 1 card"/>
+          <p:cNvPr id="4" name="Stat 1 card"/>
           <p:cNvSpPr/>
           <p:nvPr/>
         </p:nvSpPr>
@@ -4934,14 +4370,14 @@
       </p:sp>
       <p:sp>
         <p:nvSpPr>
-          <p:cNvPr id="6" name="Stat 1 value"/>
+          <p:cNvPr id="5" name="Stat 1 value"/>
           <p:cNvSpPr txBox="1"/>
           <p:nvPr/>
         </p:nvSpPr>
         <p:spPr>
           <a:xfrm>
-            <a:off x="4892040" y="1188720"/>
-            <a:ext cx="2514600" cy="1051560"/>
+            <a:off x="4937760" y="1188720"/>
+            <a:ext cx="2377440" cy="1051560"/>
           </a:xfrm>
           <a:prstGeom prst="rect">
             <a:avLst/>
@@ -4957,27 +4393,27 @@
               <a:buNone/>
             </a:pPr>
             <a:r>
-              <a:rPr lang="en-US" sz="2800" b="1" dirty="0">
+              <a:rPr lang="en-US" sz="3600" b="1" dirty="0">
                 <a:solidFill>
                   <a:schemeClr val="accent2"/>
                 </a:solidFill>
               </a:rPr>
-              <a:t>2 of 2</a:t>
-            </a:r>
-            <a:endParaRPr lang="en-US" sz="2800" dirty="0"/>
-          </a:p>
-        </p:txBody>
-      </p:sp>
-      <p:sp>
-        <p:nvSpPr>
-          <p:cNvPr id="7" name="Stat 1 text"/>
+              <a:t>2/2</a:t>
+            </a:r>
+            <a:endParaRPr lang="en-US" sz="3600" dirty="0"/>
+          </a:p>
+        </p:txBody>
+      </p:sp>
+      <p:sp>
+        <p:nvSpPr>
+          <p:cNvPr id="6" name="Stat 1 label"/>
           <p:cNvSpPr txBox="1"/>
           <p:nvPr/>
         </p:nvSpPr>
         <p:spPr>
           <a:xfrm>
-            <a:off x="7498080" y="1298448"/>
-            <a:ext cx="3977640" cy="868680"/>
+            <a:off x="7406640" y="1188720"/>
+            <a:ext cx="4069080" cy="1051560"/>
           </a:xfrm>
           <a:prstGeom prst="rect">
             <a:avLst/>
@@ -4993,40 +4429,26 @@
               <a:buNone/>
             </a:pPr>
             <a:r>
-              <a:rPr lang="en-US" sz="1500" b="1" dirty="0">
+              <a:rPr lang="en-US" sz="2000" b="1" dirty="0">
                 <a:solidFill>
                   <a:schemeClr val="bg1"/>
                 </a:solidFill>
               </a:rPr>
-              <a:t>checks passed on this run</a:t>
-            </a:r>
-            <a:endParaRPr lang="en-US" sz="1500" dirty="0"/>
-          </a:p>
-          <a:p>
-            <a:pPr indent="0" marL="0">
-              <a:buNone/>
-            </a:pPr>
-            <a:r>
-              <a:rPr lang="en-US" sz="1200" dirty="0">
-                <a:solidFill>
-                  <a:schemeClr val="bg2"/>
-                </a:solidFill>
-              </a:rPr>
-              <a:t>Up to 7 when WorkBuddy brings job-site listings. The run cannot finish until they pass.</a:t>
-            </a:r>
-            <a:endParaRPr lang="en-US" sz="1500" dirty="0"/>
-          </a:p>
-        </p:txBody>
-      </p:sp>
-      <p:sp>
-        <p:nvSpPr>
-          <p:cNvPr id="8" name="Stat 2 card"/>
+              <a:t>checks passed</a:t>
+            </a:r>
+            <a:endParaRPr lang="en-US" sz="2000" dirty="0"/>
+          </a:p>
+        </p:txBody>
+      </p:sp>
+      <p:sp>
+        <p:nvSpPr>
+          <p:cNvPr id="7" name="Stat 2 card"/>
           <p:cNvSpPr/>
           <p:nvPr/>
         </p:nvSpPr>
         <p:spPr>
           <a:xfrm>
-            <a:off x="4663440" y="2377440"/>
+            <a:off x="4663440" y="2423160"/>
             <a:ext cx="6976872" cy="1051560"/>
           </a:xfrm>
           <a:prstGeom prst="roundRect">
@@ -5042,14 +4464,14 @@
       </p:sp>
       <p:sp>
         <p:nvSpPr>
-          <p:cNvPr id="9" name="Stat 2 value"/>
+          <p:cNvPr id="8" name="Stat 2 value"/>
           <p:cNvSpPr txBox="1"/>
           <p:nvPr/>
         </p:nvSpPr>
         <p:spPr>
           <a:xfrm>
-            <a:off x="4892040" y="2377440"/>
-            <a:ext cx="2514600" cy="1051560"/>
+            <a:off x="4937760" y="2423160"/>
+            <a:ext cx="2377440" cy="1051560"/>
           </a:xfrm>
           <a:prstGeom prst="rect">
             <a:avLst/>
@@ -5065,27 +4487,27 @@
               <a:buNone/>
             </a:pPr>
             <a:r>
-              <a:rPr lang="en-US" sz="2800" b="1" dirty="0">
+              <a:rPr lang="en-US" sz="3600" b="1" dirty="0">
                 <a:solidFill>
                   <a:schemeClr val="accent1"/>
                 </a:solidFill>
               </a:rPr>
-              <a:t>RM8.72/hr</a:t>
-            </a:r>
-            <a:endParaRPr lang="en-US" sz="2800" dirty="0"/>
-          </a:p>
-        </p:txBody>
-      </p:sp>
-      <p:sp>
-        <p:nvSpPr>
-          <p:cNvPr id="10" name="Stat 2 text"/>
+              <a:t>RM8.72</a:t>
+            </a:r>
+            <a:endParaRPr lang="en-US" sz="3600" dirty="0"/>
+          </a:p>
+        </p:txBody>
+      </p:sp>
+      <p:sp>
+        <p:nvSpPr>
+          <p:cNvPr id="9" name="Stat 2 label"/>
           <p:cNvSpPr txBox="1"/>
           <p:nvPr/>
         </p:nvSpPr>
         <p:spPr>
           <a:xfrm>
-            <a:off x="7498080" y="2487168"/>
-            <a:ext cx="3977640" cy="868680"/>
+            <a:off x="7406640" y="2423160"/>
+            <a:ext cx="4069080" cy="1051560"/>
           </a:xfrm>
           <a:prstGeom prst="rect">
             <a:avLst/>
@@ -5101,40 +4523,26 @@
               <a:buNone/>
             </a:pPr>
             <a:r>
-              <a:rPr lang="en-US" sz="1500" b="1" dirty="0">
+              <a:rPr lang="en-US" sz="2000" b="1" dirty="0">
                 <a:solidFill>
                   <a:schemeClr val="bg1"/>
                 </a:solidFill>
               </a:rPr>
-              <a:t>refused from both sides</a:t>
-            </a:r>
-            <a:endParaRPr lang="en-US" sz="1500" dirty="0"/>
-          </a:p>
-          <a:p>
-            <a:pPr indent="0" marL="0">
-              <a:buNone/>
-            </a:pPr>
-            <a:r>
-              <a:rPr lang="en-US" sz="1200" dirty="0">
-                <a:solidFill>
-                  <a:schemeClr val="bg2"/>
-                </a:solidFill>
-              </a:rPr>
-              <a:t>Underpaid jobs never reach seekers. Underpaid employer posts are not published.</a:t>
-            </a:r>
-            <a:endParaRPr lang="en-US" sz="1500" dirty="0"/>
-          </a:p>
-        </p:txBody>
-      </p:sp>
-      <p:sp>
-        <p:nvSpPr>
-          <p:cNvPr id="11" name="Stat 3 card"/>
+              <a:t>legal pay floor enforced</a:t>
+            </a:r>
+            <a:endParaRPr lang="en-US" sz="2000" dirty="0"/>
+          </a:p>
+        </p:txBody>
+      </p:sp>
+      <p:sp>
+        <p:nvSpPr>
+          <p:cNvPr id="10" name="Stat 3 card"/>
           <p:cNvSpPr/>
           <p:nvPr/>
         </p:nvSpPr>
         <p:spPr>
           <a:xfrm>
-            <a:off x="4663440" y="3566160"/>
+            <a:off x="4663440" y="3657600"/>
             <a:ext cx="6976872" cy="1051560"/>
           </a:xfrm>
           <a:prstGeom prst="roundRect">
@@ -5150,14 +4558,14 @@
       </p:sp>
       <p:sp>
         <p:nvSpPr>
-          <p:cNvPr id="12" name="Stat 3 value"/>
+          <p:cNvPr id="11" name="Stat 3 value"/>
           <p:cNvSpPr txBox="1"/>
           <p:nvPr/>
         </p:nvSpPr>
         <p:spPr>
           <a:xfrm>
-            <a:off x="4892040" y="3566160"/>
-            <a:ext cx="2514600" cy="1051560"/>
+            <a:off x="4937760" y="3657600"/>
+            <a:ext cx="2377440" cy="1051560"/>
           </a:xfrm>
           <a:prstGeom prst="rect">
             <a:avLst/>
@@ -5173,27 +4581,27 @@
               <a:buNone/>
             </a:pPr>
             <a:r>
-              <a:rPr lang="en-US" sz="2800" b="1" dirty="0">
+              <a:rPr lang="en-US" sz="3600" b="1" dirty="0">
                 <a:solidFill>
                   <a:schemeClr val="accent1"/>
                 </a:solidFill>
               </a:rPr>
               <a:t>0</a:t>
             </a:r>
-            <a:endParaRPr lang="en-US" sz="2800" dirty="0"/>
-          </a:p>
-        </p:txBody>
-      </p:sp>
-      <p:sp>
-        <p:nvSpPr>
-          <p:cNvPr id="13" name="Stat 3 text"/>
+            <a:endParaRPr lang="en-US" sz="3600" dirty="0"/>
+          </a:p>
+        </p:txBody>
+      </p:sp>
+      <p:sp>
+        <p:nvSpPr>
+          <p:cNvPr id="12" name="Stat 3 label"/>
           <p:cNvSpPr txBox="1"/>
           <p:nvPr/>
         </p:nvSpPr>
         <p:spPr>
           <a:xfrm>
-            <a:off x="7498080" y="3675888"/>
-            <a:ext cx="3977640" cy="868680"/>
+            <a:off x="7406640" y="3657600"/>
+            <a:ext cx="4069080" cy="1051560"/>
           </a:xfrm>
           <a:prstGeom prst="rect">
             <a:avLst/>
@@ -5209,120 +4617,50 @@
               <a:buNone/>
             </a:pPr>
             <a:r>
-              <a:rPr lang="en-US" sz="1500" b="1" dirty="0">
+              <a:rPr lang="en-US" sz="2000" b="1" dirty="0">
                 <a:solidFill>
                   <a:schemeClr val="bg1"/>
                 </a:solidFill>
               </a:rPr>
-              <a:t>applications sent without her OK</a:t>
-            </a:r>
-            <a:endParaRPr lang="en-US" sz="1500" dirty="0"/>
-          </a:p>
+              <a:t>sent without her OK</a:t>
+            </a:r>
+            <a:endParaRPr lang="en-US" sz="2000" dirty="0"/>
+          </a:p>
+        </p:txBody>
+      </p:sp>
+      <p:sp>
+        <p:nvSpPr>
+          <p:cNvPr id="13" name="Close"/>
+          <p:cNvSpPr txBox="1"/>
+          <p:nvPr/>
+        </p:nvSpPr>
+        <p:spPr>
+          <a:xfrm>
+            <a:off x="4663440" y="5120640"/>
+            <a:ext cx="6976872" cy="548640"/>
+          </a:xfrm>
+          <a:prstGeom prst="rect">
+            <a:avLst/>
+          </a:prstGeom>
+          <a:noFill/>
+          <a:ln/>
+        </p:spPr>
+        <p:txBody>
+          <a:bodyPr wrap="square" lIns="0" tIns="0" rIns="0" bIns="0" rtlCol="0" anchor="ctr"/>
+          <a:lstStyle/>
           <a:p>
             <a:pPr indent="0" marL="0">
               <a:buNone/>
             </a:pPr>
             <a:r>
-              <a:rPr lang="en-US" sz="1200" dirty="0">
-                <a:solidFill>
-                  <a:schemeClr val="bg2"/>
-                </a:solidFill>
-              </a:rPr>
-              <a:t>She selects a job; only then is it sent.</a:t>
-            </a:r>
-            <a:endParaRPr lang="en-US" sz="1500" dirty="0"/>
-          </a:p>
-        </p:txBody>
-      </p:sp>
-      <p:sp>
-        <p:nvSpPr>
-          <p:cNvPr id="14" name="Accessibility"/>
-          <p:cNvSpPr txBox="1"/>
-          <p:nvPr/>
-        </p:nvSpPr>
-        <p:spPr>
-          <a:xfrm>
-            <a:off x="4663440" y="4800600"/>
-            <a:ext cx="6976872" cy="457200"/>
-          </a:xfrm>
-          <a:prstGeom prst="rect">
-            <a:avLst/>
-          </a:prstGeom>
-          <a:noFill/>
-          <a:ln/>
-        </p:spPr>
-        <p:txBody>
-          <a:bodyPr wrap="square" lIns="0" tIns="0" rIns="0" bIns="0" rtlCol="0" anchor="t"/>
-          <a:lstStyle/>
-          <a:p>
-            <a:pPr indent="0" marL="0">
-              <a:buNone/>
-            </a:pPr>
-            <a:r>
-              <a:rPr lang="en-US" sz="1300" dirty="0">
-                <a:solidFill>
-                  <a:schemeClr val="bg2"/>
-                </a:solidFill>
-              </a:rPr>
-              <a:t>Web app: WCAG 2.2 AA, 7:1 contrast, full keyboard and screen-reader support.</a:t>
-            </a:r>
-            <a:endParaRPr lang="en-US" sz="1300" dirty="0"/>
-          </a:p>
-        </p:txBody>
-      </p:sp>
-      <p:sp>
-        <p:nvSpPr>
-          <p:cNvPr id="15" name="Close"/>
-          <p:cNvSpPr txBox="1"/>
-          <p:nvPr/>
-        </p:nvSpPr>
-        <p:spPr>
-          <a:xfrm>
-            <a:off x="4663440" y="5303520"/>
-            <a:ext cx="6976872" cy="914400"/>
-          </a:xfrm>
-          <a:prstGeom prst="rect">
-            <a:avLst/>
-          </a:prstGeom>
-          <a:noFill/>
-          <a:ln/>
-        </p:spPr>
-        <p:txBody>
-          <a:bodyPr wrap="square" lIns="0" tIns="0" rIns="0" bIns="0" rtlCol="0" anchor="t"/>
-          <a:lstStyle/>
-          <a:p>
-            <a:pPr indent="0" marL="0">
-              <a:spcAft>
-                <a:spcPts val="600"/>
-              </a:spcAft>
-              <a:buNone/>
-            </a:pPr>
-            <a:r>
-              <a:rPr lang="en-US" sz="1600" b="1" dirty="0">
-                <a:solidFill>
-                  <a:schemeClr val="bg1"/>
-                </a:solidFill>
-              </a:rPr>
-              <a:t>One sentence in. Two suitable jobs, a reason for every rejection, nothing sent without her say-so.</a:t>
-            </a:r>
-            <a:endParaRPr lang="en-US" sz="1600" dirty="0"/>
-          </a:p>
-          <a:p>
-            <a:pPr indent="0" marL="0">
-              <a:spcAft>
-                <a:spcPts val="600"/>
-              </a:spcAft>
-              <a:buNone/>
-            </a:pPr>
-            <a:r>
-              <a:rPr lang="en-US" sz="1600" b="1" dirty="0">
+              <a:rPr lang="en-US" sz="2400" b="1" dirty="0">
                 <a:solidFill>
                   <a:schemeClr val="accent1"/>
                 </a:solidFill>
               </a:rPr>
               <a:t>HireBuddy: work that gets done.</a:t>
             </a:r>
-            <a:endParaRPr lang="en-US" sz="1600" dirty="0"/>
+            <a:endParaRPr lang="en-US" sz="2400" dirty="0"/>
           </a:p>
         </p:txBody>
       </p:sp>

</xml_diff>

<commit_message>
Proof slide: result screenshot only
Co-Authored-By: Claude Opus 5.5 <noreply@anthropic.com>
</commit_message>
<xml_diff>
--- a/hirebuddy-pitch.pptx
+++ b/hirebuddy-pitch.pptx
@@ -113,24 +113,24 @@
   <p:extLst>
     <p:ext uri="{521415D9-36F7-43E2-AB2F-B90AF26B5E84}">
       <p14:sectionLst xmlns:p14="http://schemas.microsoft.com/office/powerpoint/2010/main">
-        <p14:section name="Problem" id="{ab1cd84f-84d0-fcc4-df39-1af7d8c46d40}">
+        <p14:section name="Problem" id="{666f9b09-1e73-0474-6d6d-4633b6b5cfbd}">
           <p14:sldIdLst>
             <p14:sldId id="256"/>
           </p14:sldIdLst>
         </p14:section>
-        <p14:section name="Solution" id="{d377a365-bd39-07ec-eb43-a4c84769dab2}">
+        <p14:section name="Solution" id="{b3171373-38fc-ada6-91bf-3eb0e5907fb4}">
           <p14:sldIdLst>
             <p14:sldId id="257"/>
             <p14:sldId id="258"/>
           </p14:sldIdLst>
         </p14:section>
-        <p14:section name="How it works" id="{177309f3-cc36-6a8b-f5b6-bda89b43a69f}">
+        <p14:section name="How it works" id="{3f28f560-a82b-cd6c-67bf-b9d291deaf9f}">
           <p14:sldIdLst>
             <p14:sldId id="259"/>
             <p14:sldId id="260"/>
           </p14:sldIdLst>
         </p14:section>
-        <p14:section name="Close" id="{54755c53-a337-b894-a485-ae68158c5d69}">
+        <p14:section name="Close" id="{f8c5cea5-f9df-dfea-c6be-dda848fc4885}">
           <p14:sldIdLst>
             <p14:sldId id="261"/>
             <p14:sldId id="262"/>
@@ -898,8 +898,8 @@
             <a:r>
               <a:rPr lang="en-US" dirty="0"/>
               <a:t>[2:00-2:35 | 35s]
-[ACTION: switch to WorkBuddy and show the finished result. If it is not ready, point at the screenshot here.]
-One sentence in. Two suitable jobs, each with a match score and the reason it suits her. Every check passed. Nothing below the RM8.72 legal minimum, from either side. No job that needs sight. And zero applications sent without her say-so.</a:t>
+[ACTION: switch to WorkBuddy and show the finished result. If it is not ready, use this screenshot.]
+One sentence in. Two suitable jobs, each with a match score and the reason it suits her. Checked and verified. Nothing below the RM8.72 legal minimum, no job that needs sight, and nothing is sent until she presses Apply. HireBuddy: work that gets done.</a:t>
             </a:r>
             <a:endParaRPr lang="en-US" dirty="0"/>
           </a:p>
@@ -4324,7 +4324,7 @@
       </p:sp>
       <p:pic>
         <p:nvPicPr>
-          <p:cNvPr id="3" name="Result screenshot" descr="HireBuddy result page for Nadia: 2 suitable jobs with match scores, checked and verified, 2 of 2 checks passed">    </p:cNvPr>
+          <p:cNvPr id="3" name="Seeker result screenshot" descr="HireBuddy result for Nadia: 2 suitable jobs with match scores, checked and verified, 2 of 2 checks passed">    </p:cNvPr>
           <p:cNvPicPr>
             <a:picLocks noChangeAspect="1"/>
           </p:cNvPicPr>
@@ -4338,7 +4338,7 @@
         </p:blipFill>
         <p:spPr>
           <a:xfrm>
-            <a:off x="548640" y="1188720"/>
+            <a:off x="4178808" y="1188720"/>
             <a:ext cx="3831336" cy="4800600"/>
           </a:xfrm>
           <a:prstGeom prst="rect">
@@ -4346,324 +4346,6 @@
           </a:prstGeom>
         </p:spPr>
       </p:pic>
-      <p:sp>
-        <p:nvSpPr>
-          <p:cNvPr id="4" name="Stat 1 card"/>
-          <p:cNvSpPr/>
-          <p:nvPr/>
-        </p:nvSpPr>
-        <p:spPr>
-          <a:xfrm>
-            <a:off x="4663440" y="1188720"/>
-            <a:ext cx="6976872" cy="1051560"/>
-          </a:xfrm>
-          <a:prstGeom prst="roundRect">
-            <a:avLst>
-              <a:gd name="adj" fmla="val 6957"/>
-            </a:avLst>
-          </a:prstGeom>
-          <a:solidFill>
-            <a:srgbClr val="1E293B"/>
-          </a:solidFill>
-          <a:ln/>
-        </p:spPr>
-      </p:sp>
-      <p:sp>
-        <p:nvSpPr>
-          <p:cNvPr id="5" name="Stat 1 value"/>
-          <p:cNvSpPr txBox="1"/>
-          <p:nvPr/>
-        </p:nvSpPr>
-        <p:spPr>
-          <a:xfrm>
-            <a:off x="4937760" y="1188720"/>
-            <a:ext cx="2377440" cy="1051560"/>
-          </a:xfrm>
-          <a:prstGeom prst="rect">
-            <a:avLst/>
-          </a:prstGeom>
-          <a:noFill/>
-          <a:ln/>
-        </p:spPr>
-        <p:txBody>
-          <a:bodyPr wrap="square" lIns="0" tIns="0" rIns="0" bIns="0" rtlCol="0" anchor="ctr"/>
-          <a:lstStyle/>
-          <a:p>
-            <a:pPr indent="0" marL="0">
-              <a:buNone/>
-            </a:pPr>
-            <a:r>
-              <a:rPr lang="en-US" sz="3600" b="1" dirty="0">
-                <a:solidFill>
-                  <a:schemeClr val="accent2"/>
-                </a:solidFill>
-              </a:rPr>
-              <a:t>2/2</a:t>
-            </a:r>
-            <a:endParaRPr lang="en-US" sz="3600" dirty="0"/>
-          </a:p>
-        </p:txBody>
-      </p:sp>
-      <p:sp>
-        <p:nvSpPr>
-          <p:cNvPr id="6" name="Stat 1 label"/>
-          <p:cNvSpPr txBox="1"/>
-          <p:nvPr/>
-        </p:nvSpPr>
-        <p:spPr>
-          <a:xfrm>
-            <a:off x="7406640" y="1188720"/>
-            <a:ext cx="4069080" cy="1051560"/>
-          </a:xfrm>
-          <a:prstGeom prst="rect">
-            <a:avLst/>
-          </a:prstGeom>
-          <a:noFill/>
-          <a:ln/>
-        </p:spPr>
-        <p:txBody>
-          <a:bodyPr wrap="square" lIns="0" tIns="0" rIns="0" bIns="0" rtlCol="0" anchor="ctr"/>
-          <a:lstStyle/>
-          <a:p>
-            <a:pPr indent="0" marL="0">
-              <a:buNone/>
-            </a:pPr>
-            <a:r>
-              <a:rPr lang="en-US" sz="2000" b="1" dirty="0">
-                <a:solidFill>
-                  <a:schemeClr val="bg1"/>
-                </a:solidFill>
-              </a:rPr>
-              <a:t>checks passed</a:t>
-            </a:r>
-            <a:endParaRPr lang="en-US" sz="2000" dirty="0"/>
-          </a:p>
-        </p:txBody>
-      </p:sp>
-      <p:sp>
-        <p:nvSpPr>
-          <p:cNvPr id="7" name="Stat 2 card"/>
-          <p:cNvSpPr/>
-          <p:nvPr/>
-        </p:nvSpPr>
-        <p:spPr>
-          <a:xfrm>
-            <a:off x="4663440" y="2423160"/>
-            <a:ext cx="6976872" cy="1051560"/>
-          </a:xfrm>
-          <a:prstGeom prst="roundRect">
-            <a:avLst>
-              <a:gd name="adj" fmla="val 6957"/>
-            </a:avLst>
-          </a:prstGeom>
-          <a:solidFill>
-            <a:srgbClr val="1E293B"/>
-          </a:solidFill>
-          <a:ln/>
-        </p:spPr>
-      </p:sp>
-      <p:sp>
-        <p:nvSpPr>
-          <p:cNvPr id="8" name="Stat 2 value"/>
-          <p:cNvSpPr txBox="1"/>
-          <p:nvPr/>
-        </p:nvSpPr>
-        <p:spPr>
-          <a:xfrm>
-            <a:off x="4937760" y="2423160"/>
-            <a:ext cx="2377440" cy="1051560"/>
-          </a:xfrm>
-          <a:prstGeom prst="rect">
-            <a:avLst/>
-          </a:prstGeom>
-          <a:noFill/>
-          <a:ln/>
-        </p:spPr>
-        <p:txBody>
-          <a:bodyPr wrap="square" lIns="0" tIns="0" rIns="0" bIns="0" rtlCol="0" anchor="ctr"/>
-          <a:lstStyle/>
-          <a:p>
-            <a:pPr indent="0" marL="0">
-              <a:buNone/>
-            </a:pPr>
-            <a:r>
-              <a:rPr lang="en-US" sz="3600" b="1" dirty="0">
-                <a:solidFill>
-                  <a:schemeClr val="accent1"/>
-                </a:solidFill>
-              </a:rPr>
-              <a:t>RM8.72</a:t>
-            </a:r>
-            <a:endParaRPr lang="en-US" sz="3600" dirty="0"/>
-          </a:p>
-        </p:txBody>
-      </p:sp>
-      <p:sp>
-        <p:nvSpPr>
-          <p:cNvPr id="9" name="Stat 2 label"/>
-          <p:cNvSpPr txBox="1"/>
-          <p:nvPr/>
-        </p:nvSpPr>
-        <p:spPr>
-          <a:xfrm>
-            <a:off x="7406640" y="2423160"/>
-            <a:ext cx="4069080" cy="1051560"/>
-          </a:xfrm>
-          <a:prstGeom prst="rect">
-            <a:avLst/>
-          </a:prstGeom>
-          <a:noFill/>
-          <a:ln/>
-        </p:spPr>
-        <p:txBody>
-          <a:bodyPr wrap="square" lIns="0" tIns="0" rIns="0" bIns="0" rtlCol="0" anchor="ctr"/>
-          <a:lstStyle/>
-          <a:p>
-            <a:pPr indent="0" marL="0">
-              <a:buNone/>
-            </a:pPr>
-            <a:r>
-              <a:rPr lang="en-US" sz="2000" b="1" dirty="0">
-                <a:solidFill>
-                  <a:schemeClr val="bg1"/>
-                </a:solidFill>
-              </a:rPr>
-              <a:t>legal pay floor enforced</a:t>
-            </a:r>
-            <a:endParaRPr lang="en-US" sz="2000" dirty="0"/>
-          </a:p>
-        </p:txBody>
-      </p:sp>
-      <p:sp>
-        <p:nvSpPr>
-          <p:cNvPr id="10" name="Stat 3 card"/>
-          <p:cNvSpPr/>
-          <p:nvPr/>
-        </p:nvSpPr>
-        <p:spPr>
-          <a:xfrm>
-            <a:off x="4663440" y="3657600"/>
-            <a:ext cx="6976872" cy="1051560"/>
-          </a:xfrm>
-          <a:prstGeom prst="roundRect">
-            <a:avLst>
-              <a:gd name="adj" fmla="val 6957"/>
-            </a:avLst>
-          </a:prstGeom>
-          <a:solidFill>
-            <a:srgbClr val="1E293B"/>
-          </a:solidFill>
-          <a:ln/>
-        </p:spPr>
-      </p:sp>
-      <p:sp>
-        <p:nvSpPr>
-          <p:cNvPr id="11" name="Stat 3 value"/>
-          <p:cNvSpPr txBox="1"/>
-          <p:nvPr/>
-        </p:nvSpPr>
-        <p:spPr>
-          <a:xfrm>
-            <a:off x="4937760" y="3657600"/>
-            <a:ext cx="2377440" cy="1051560"/>
-          </a:xfrm>
-          <a:prstGeom prst="rect">
-            <a:avLst/>
-          </a:prstGeom>
-          <a:noFill/>
-          <a:ln/>
-        </p:spPr>
-        <p:txBody>
-          <a:bodyPr wrap="square" lIns="0" tIns="0" rIns="0" bIns="0" rtlCol="0" anchor="ctr"/>
-          <a:lstStyle/>
-          <a:p>
-            <a:pPr indent="0" marL="0">
-              <a:buNone/>
-            </a:pPr>
-            <a:r>
-              <a:rPr lang="en-US" sz="3600" b="1" dirty="0">
-                <a:solidFill>
-                  <a:schemeClr val="accent1"/>
-                </a:solidFill>
-              </a:rPr>
-              <a:t>0</a:t>
-            </a:r>
-            <a:endParaRPr lang="en-US" sz="3600" dirty="0"/>
-          </a:p>
-        </p:txBody>
-      </p:sp>
-      <p:sp>
-        <p:nvSpPr>
-          <p:cNvPr id="12" name="Stat 3 label"/>
-          <p:cNvSpPr txBox="1"/>
-          <p:nvPr/>
-        </p:nvSpPr>
-        <p:spPr>
-          <a:xfrm>
-            <a:off x="7406640" y="3657600"/>
-            <a:ext cx="4069080" cy="1051560"/>
-          </a:xfrm>
-          <a:prstGeom prst="rect">
-            <a:avLst/>
-          </a:prstGeom>
-          <a:noFill/>
-          <a:ln/>
-        </p:spPr>
-        <p:txBody>
-          <a:bodyPr wrap="square" lIns="0" tIns="0" rIns="0" bIns="0" rtlCol="0" anchor="ctr"/>
-          <a:lstStyle/>
-          <a:p>
-            <a:pPr indent="0" marL="0">
-              <a:buNone/>
-            </a:pPr>
-            <a:r>
-              <a:rPr lang="en-US" sz="2000" b="1" dirty="0">
-                <a:solidFill>
-                  <a:schemeClr val="bg1"/>
-                </a:solidFill>
-              </a:rPr>
-              <a:t>sent without her OK</a:t>
-            </a:r>
-            <a:endParaRPr lang="en-US" sz="2000" dirty="0"/>
-          </a:p>
-        </p:txBody>
-      </p:sp>
-      <p:sp>
-        <p:nvSpPr>
-          <p:cNvPr id="13" name="Close"/>
-          <p:cNvSpPr txBox="1"/>
-          <p:nvPr/>
-        </p:nvSpPr>
-        <p:spPr>
-          <a:xfrm>
-            <a:off x="4663440" y="5120640"/>
-            <a:ext cx="6976872" cy="548640"/>
-          </a:xfrm>
-          <a:prstGeom prst="rect">
-            <a:avLst/>
-          </a:prstGeom>
-          <a:noFill/>
-          <a:ln/>
-        </p:spPr>
-        <p:txBody>
-          <a:bodyPr wrap="square" lIns="0" tIns="0" rIns="0" bIns="0" rtlCol="0" anchor="ctr"/>
-          <a:lstStyle/>
-          <a:p>
-            <a:pPr indent="0" marL="0">
-              <a:buNone/>
-            </a:pPr>
-            <a:r>
-              <a:rPr lang="en-US" sz="2400" b="1" dirty="0">
-                <a:solidFill>
-                  <a:schemeClr val="accent1"/>
-                </a:solidFill>
-              </a:rPr>
-              <a:t>HireBuddy: work that gets done.</a:t>
-            </a:r>
-            <a:endParaRPr lang="en-US" sz="2400" dirty="0"/>
-          </a:p>
-        </p:txBody>
-      </p:sp>
       <p:sp>
         <p:nvSpPr>
           <p:cNvPr id="25" name="Slide Number Placeholder 0"/>

</xml_diff>

<commit_message>
Backup slide: real WorkBuddy run with job-site listings
Co-Authored-By: Claude Opus 5.5 <noreply@anthropic.com>
</commit_message>
<xml_diff>
--- a/hirebuddy-pitch.pptx
+++ b/hirebuddy-pitch.pptx
@@ -113,24 +113,24 @@
   <p:extLst>
     <p:ext uri="{521415D9-36F7-43E2-AB2F-B90AF26B5E84}">
       <p14:sectionLst xmlns:p14="http://schemas.microsoft.com/office/powerpoint/2010/main">
-        <p14:section name="Problem" id="{666f9b09-1e73-0474-6d6d-4633b6b5cfbd}">
+        <p14:section name="Problem" id="{27f3d069-a126-c441-4b79-4f9ed1e9e6bc}">
           <p14:sldIdLst>
             <p14:sldId id="256"/>
           </p14:sldIdLst>
         </p14:section>
-        <p14:section name="Solution" id="{b3171373-38fc-ada6-91bf-3eb0e5907fb4}">
+        <p14:section name="Solution" id="{f60ad320-7547-1dad-47d3-a530a3b7262e}">
           <p14:sldIdLst>
             <p14:sldId id="257"/>
             <p14:sldId id="258"/>
           </p14:sldIdLst>
         </p14:section>
-        <p14:section name="How it works" id="{3f28f560-a82b-cd6c-67bf-b9d291deaf9f}">
+        <p14:section name="How it works" id="{af63021c-4878-e47f-b877-cf6dc8a9146a}">
           <p14:sldIdLst>
             <p14:sldId id="259"/>
             <p14:sldId id="260"/>
           </p14:sldIdLst>
         </p14:section>
-        <p14:section name="Close" id="{f8c5cea5-f9df-dfea-c6be-dda848fc4885}">
+        <p14:section name="Close" id="{9516d726-f73d-2573-830b-02eb4d915f6d}">
           <p14:sldIdLst>
             <p14:sldId id="261"/>
             <p14:sldId id="262"/>
@@ -1077,7 +1077,7 @@
           <a:p>
             <a:r>
               <a:rPr lang="en-US" dirty="0"/>
-              <a:t>Hidden slide. Only jump here if WorkBuddy is slow or fails on stage. During rehearsal, replace both frames with screenshots of a finished WorkBuddy run for the slide 2 sentence.</a:t>
+              <a:t>Hidden slide. Only jump here if the live WorkBuddy demo is slow or fails. Say: Here is a real run WorkBuddy did end to end, for another job seeker, Nur Aqilah, who has low vision and needs remote work. WorkBuddy found 20 real listings on job sites. HireBuddy checked every one, gave a reason for each it rejected, found the one that suits her, drafted an application for one worth asking about, and passed all 6 checks. Nothing was sent.</a:t>
             </a:r>
             <a:endParaRPr lang="en-US" dirty="0"/>
           </a:p>
@@ -4842,138 +4842,60 @@
                   <a:schemeClr val="accent1"/>
                 </a:solidFill>
               </a:rPr>
-              <a:t>Backup: WorkBuddy Run</a:t>
+              <a:t>Backup: Real WorkBuddy Run</a:t>
             </a:r>
             <a:endParaRPr lang="en-US" sz="3000" dirty="0"/>
           </a:p>
         </p:txBody>
       </p:sp>
-      <p:sp>
-        <p:nvSpPr>
-          <p:cNvPr id="3" name="Backup frame 1"/>
-          <p:cNvSpPr/>
-          <p:nvPr/>
-        </p:nvSpPr>
+      <p:pic>
+        <p:nvPicPr>
+          <p:cNvPr id="3" name="WorkBuddy result screenshot" descr="HireBuddy run driven by WorkBuddy: Nur Aqilah, low vision, remote only. Checked and verified, 1 suitable job, Bahasa Melayu Content Writer, 88 out of 100">    </p:cNvPr>
+          <p:cNvPicPr>
+            <a:picLocks noChangeAspect="1"/>
+          </p:cNvPicPr>
+          <p:nvPr/>
+        </p:nvPicPr>
+        <p:blipFill>
+          <a:blip r:embed="rId1"/>
+          <a:stretch>
+            <a:fillRect/>
+          </a:stretch>
+        </p:blipFill>
         <p:spPr>
           <a:xfrm>
             <a:off x="548640" y="1188720"/>
-            <a:ext cx="5404104" cy="4754880"/>
-          </a:xfrm>
-          <a:prstGeom prst="roundRect">
-            <a:avLst>
-              <a:gd name="adj" fmla="val 1538"/>
-            </a:avLst>
-          </a:prstGeom>
-          <a:solidFill>
-            <a:srgbClr val="1E293B"/>
-          </a:solidFill>
-          <a:ln w="12700">
-            <a:solidFill>
-              <a:srgbClr val="94A3B8"/>
-            </a:solidFill>
-            <a:prstDash val="dash"/>
-          </a:ln>
-        </p:spPr>
-      </p:sp>
-      <p:sp>
-        <p:nvSpPr>
-          <p:cNvPr id="4" name="Backup label 1"/>
-          <p:cNvSpPr txBox="1"/>
-          <p:nvPr/>
-        </p:nvSpPr>
-        <p:spPr>
-          <a:xfrm>
-            <a:off x="548640" y="3291840"/>
-            <a:ext cx="5404104" cy="457200"/>
-          </a:xfrm>
-          <a:prstGeom prst="rect">
-            <a:avLst/>
-          </a:prstGeom>
-          <a:noFill/>
-          <a:ln/>
-        </p:spPr>
-        <p:txBody>
-          <a:bodyPr wrap="square" lIns="0" tIns="0" rIns="0" bIns="0" rtlCol="0" anchor="ctr"/>
-          <a:lstStyle/>
-          <a:p>
-            <a:pPr algn="ctr" indent="0" marL="0">
-              <a:buNone/>
-            </a:pPr>
-            <a:r>
-              <a:rPr lang="en-US" sz="1600" dirty="0">
-                <a:solidFill>
-                  <a:schemeClr val="bg2"/>
-                </a:solidFill>
-              </a:rPr>
-              <a:t>Paste screenshot: WorkBuddy result message</a:t>
-            </a:r>
-            <a:endParaRPr lang="en-US" sz="1600" dirty="0"/>
-          </a:p>
-        </p:txBody>
-      </p:sp>
-      <p:sp>
-        <p:nvSpPr>
-          <p:cNvPr id="5" name="Backup frame 2"/>
-          <p:cNvSpPr/>
-          <p:nvPr/>
-        </p:nvSpPr>
-        <p:spPr>
-          <a:xfrm>
-            <a:off x="6236208" y="1188720"/>
-            <a:ext cx="5404104" cy="4754880"/>
-          </a:xfrm>
-          <a:prstGeom prst="roundRect">
-            <a:avLst>
-              <a:gd name="adj" fmla="val 1538"/>
-            </a:avLst>
-          </a:prstGeom>
-          <a:solidFill>
-            <a:srgbClr val="1E293B"/>
-          </a:solidFill>
-          <a:ln w="12700">
-            <a:solidFill>
-              <a:srgbClr val="94A3B8"/>
-            </a:solidFill>
-            <a:prstDash val="dash"/>
-          </a:ln>
-        </p:spPr>
-      </p:sp>
-      <p:sp>
-        <p:nvSpPr>
-          <p:cNvPr id="6" name="Backup label 2"/>
-          <p:cNvSpPr txBox="1"/>
-          <p:nvPr/>
-        </p:nvSpPr>
-        <p:spPr>
-          <a:xfrm>
-            <a:off x="6236208" y="3291840"/>
-            <a:ext cx="5404104" cy="457200"/>
-          </a:xfrm>
-          <a:prstGeom prst="rect">
-            <a:avLst/>
-          </a:prstGeom>
-          <a:noFill/>
-          <a:ln/>
-        </p:spPr>
-        <p:txBody>
-          <a:bodyPr wrap="square" lIns="0" tIns="0" rIns="0" bIns="0" rtlCol="0" anchor="ctr"/>
-          <a:lstStyle/>
-          <a:p>
-            <a:pPr algn="ctr" indent="0" marL="0">
-              <a:buNone/>
-            </a:pPr>
-            <a:r>
-              <a:rPr lang="en-US" sz="1600" dirty="0">
-                <a:solidFill>
-                  <a:schemeClr val="bg2"/>
-                </a:solidFill>
-              </a:rPr>
-              <a:t>Paste screenshot: Saved files + run log</a:t>
-            </a:r>
-            <a:endParaRPr lang="en-US" sz="1600" dirty="0"/>
-          </a:p>
-        </p:txBody>
-      </p:sp>
+            <a:ext cx="5404104" cy="4242816"/>
+          </a:xfrm>
+          <a:prstGeom prst="rect">
+            <a:avLst/>
+          </a:prstGeom>
+        </p:spPr>
+      </p:pic>
+      <p:pic>
+        <p:nvPicPr>
+          <p:cNvPr id="4" name="Job-site listings screenshot" descr="Jobs WorkBuddy found on other sites, each scored, rejected with a reason: not remote">    </p:cNvPr>
+          <p:cNvPicPr>
+            <a:picLocks noChangeAspect="1"/>
+          </p:cNvPicPr>
+          <p:nvPr/>
+        </p:nvPicPr>
+        <p:blipFill>
+          <a:blip r:embed="rId2"/>
+          <a:stretch>
+            <a:fillRect/>
+          </a:stretch>
+        </p:blipFill>
+        <p:spPr>
+          <a:xfrm>
+            <a:off x="6355080" y="1188720"/>
+            <a:ext cx="4864608" cy="4754880"/>
+          </a:xfrm>
+          <a:prstGeom prst="rect">
+            <a:avLst/>
+          </a:prstGeom>
+        </p:spPr>
+      </p:pic>
       <p:sp>
         <p:nvSpPr>
           <p:cNvPr id="25" name="Slide Number Placeholder 0"/>

</xml_diff>

<commit_message>
Closing slide answers the track's guiding question
Co-Authored-By: Claude Opus 5.5 <noreply@anthropic.com>
</commit_message>
<xml_diff>
--- a/hirebuddy-pitch.pptx
+++ b/hirebuddy-pitch.pptx
@@ -113,24 +113,24 @@
   <p:extLst>
     <p:ext uri="{521415D9-36F7-43E2-AB2F-B90AF26B5E84}">
       <p14:sectionLst xmlns:p14="http://schemas.microsoft.com/office/powerpoint/2010/main">
-        <p14:section name="Problem" id="{27f3d069-a126-c441-4b79-4f9ed1e9e6bc}">
+        <p14:section name="Problem" id="{14e4025f-abad-a43f-85d5-2438340237f9}">
           <p14:sldIdLst>
             <p14:sldId id="256"/>
           </p14:sldIdLst>
         </p14:section>
-        <p14:section name="Solution" id="{f60ad320-7547-1dad-47d3-a530a3b7262e}">
+        <p14:section name="Solution" id="{eec39c1c-8bf1-7999-fa1c-c457c5d54756}">
           <p14:sldIdLst>
             <p14:sldId id="257"/>
             <p14:sldId id="258"/>
           </p14:sldIdLst>
         </p14:section>
-        <p14:section name="How it works" id="{af63021c-4878-e47f-b877-cf6dc8a9146a}">
+        <p14:section name="How it works" id="{c49cd280-8668-db5a-b49d-d21fc3447d5e}">
           <p14:sldIdLst>
             <p14:sldId id="259"/>
             <p14:sldId id="260"/>
           </p14:sldIdLst>
         </p14:section>
-        <p14:section name="Close" id="{9516d726-f73d-2573-830b-02eb4d915f6d}">
+        <p14:section name="Close" id="{e2fd213b-a5f7-9dca-85ac-0a679064ed58}">
           <p14:sldIdLst>
             <p14:sldId id="261"/>
             <p14:sldId id="262"/>
@@ -719,8 +719,8 @@
           <a:p>
             <a:r>
               <a:rPr lang="en-US" dirty="0"/>
-              <a:t>[0:45-1:25 | 40s]
-WorkBuddy is the engine. Our skill gives it the plan. It finds her resume in Documents, then searches JobStreet, Indeed and Hiredly while HireBuddy saves her profile, in parallel. Our tools check every job, verify the result, and save it on her computer. WorkBuddy also runs a daily check, takes requests by Telegram, and sends the application she chooses from her own email.</a:t>
+              <a:t>[0:45-1:20 | 35s]
+WorkBuddy is the engine. Our skill gives it the plan. It finds her resume, then searches the job sites while HireBuddy saves her profile, in parallel. Our tools check every job, verify the result, and save it on her computer. Local files, web search, automations, Telegram, email: all WorkBuddy.</a:t>
             </a:r>
             <a:endParaRPr lang="en-US" dirty="0"/>
           </a:p>
@@ -808,8 +808,8 @@
           <a:p>
             <a:r>
               <a:rPr lang="en-US" dirty="0"/>
-              <a:t>[1:25-2:00 | 35s]
-This is the real run on that sentence. Round one found only two jobs that fit. So the agent tested five ways to widen the search, simulating each one first. None added a job that actually suits her, so it stopped and told her what came closest, instead of padding the list with bad fits. Lowering her pay floor? It won't do that without her OK. And it cannot finish until verification passes.</a:t>
+              <a:t>[1:20-1:50 | 30s]
+This is the real run. Only two jobs fit, so the agent tested five ways to widen the search. None helped, so it stopped instead of padding the list with bad fits. Lowering her pay? It asks her first. And it can't finish until verification passes.</a:t>
             </a:r>
             <a:endParaRPr lang="en-US" dirty="0"/>
           </a:p>
@@ -897,9 +897,9 @@
           <a:p>
             <a:r>
               <a:rPr lang="en-US" dirty="0"/>
-              <a:t>[2:00-2:35 | 35s]
+              <a:t>[1:50-2:20 | 30s]
 [ACTION: switch to WorkBuddy and show the finished result. If it is not ready, use this screenshot.]
-One sentence in. Two suitable jobs, each with a match score and the reason it suits her. Checked and verified. Nothing below the RM8.72 legal minimum, no job that needs sight, and nothing is sent until she presses Apply. HireBuddy: work that gets done.</a:t>
+Two suitable jobs, each scored, checked and verified. Nothing under the legal minimum, nothing that needs sight, and nothing sent until she presses Apply.</a:t>
             </a:r>
             <a:endParaRPr lang="en-US" dirty="0"/>
           </a:p>
@@ -987,8 +987,8 @@
           <a:p>
             <a:r>
               <a:rPr lang="en-US" dirty="0"/>
-              <a:t>[2:35-2:50 | 15s]
-Scan to try it with Nadia's sentence or your own. HireBuddy: work that gets done. Thank you.
+              <a:t>[2:20-2:40 | 20s]
+So, can our agent use WorkBuddy to solve a real problem and get things done? Real problem: blind job seekers lose hours every search. WorkBuddy is the engine. And it gets it done, with her OK. Scan to try it. Thank you.
 [Before presenting: open the live app a minute early, because the free server takes about a minute to wake up.]</a:t>
             </a:r>
             <a:endParaRPr lang="en-US" dirty="0"/>
@@ -4448,7 +4448,7 @@
                   <a:schemeClr val="accent1"/>
                 </a:solidFill>
               </a:rPr>
-              <a:t>Try It: One Sentence</a:t>
+              <a:t>Can It Use WorkBuddy to Get Things Done?</a:t>
             </a:r>
             <a:endParaRPr lang="en-US" sz="3000" dirty="0"/>
           </a:p>
@@ -4456,29 +4456,325 @@
       </p:sp>
       <p:sp>
         <p:nvSpPr>
-          <p:cNvPr id="3" name="QR card 1"/>
+          <p:cNvPr id="3" name="Answer 1 check"/>
           <p:cNvSpPr/>
           <p:nvPr/>
         </p:nvSpPr>
         <p:spPr>
           <a:xfrm>
-            <a:off x="1737360" y="1280160"/>
-            <a:ext cx="3931920" cy="4023360"/>
-          </a:xfrm>
-          <a:prstGeom prst="roundRect">
-            <a:avLst>
-              <a:gd name="adj" fmla="val 2326"/>
-            </a:avLst>
-          </a:prstGeom>
-          <a:solidFill>
-            <a:srgbClr val="1E293B"/>
-          </a:solidFill>
-          <a:ln/>
-        </p:spPr>
+            <a:off x="548640" y="1463040"/>
+            <a:ext cx="548640" cy="548640"/>
+          </a:xfrm>
+          <a:prstGeom prst="ellipse">
+            <a:avLst/>
+          </a:prstGeom>
+          <a:solidFill>
+            <a:srgbClr val="10B981"/>
+          </a:solidFill>
+          <a:ln/>
+        </p:spPr>
+      </p:sp>
+      <p:sp>
+        <p:nvSpPr>
+          <p:cNvPr id="4" name="Answer 1 tick"/>
+          <p:cNvSpPr txBox="1"/>
+          <p:nvPr/>
+        </p:nvSpPr>
+        <p:spPr>
+          <a:xfrm>
+            <a:off x="548640" y="1463040"/>
+            <a:ext cx="548640" cy="548640"/>
+          </a:xfrm>
+          <a:prstGeom prst="rect">
+            <a:avLst/>
+          </a:prstGeom>
+          <a:noFill/>
+          <a:ln/>
+        </p:spPr>
+        <p:txBody>
+          <a:bodyPr wrap="square" lIns="0" tIns="0" rIns="0" bIns="0" rtlCol="0" anchor="ctr"/>
+          <a:lstStyle/>
+          <a:p>
+            <a:pPr algn="ctr" indent="0" marL="0">
+              <a:buNone/>
+            </a:pPr>
+            <a:r>
+              <a:rPr lang="en-US" sz="2400" b="1" dirty="0">
+                <a:solidFill>
+                  <a:schemeClr val="bg1"/>
+                </a:solidFill>
+              </a:rPr>
+              <a:t>✓</a:t>
+            </a:r>
+            <a:endParaRPr lang="en-US" sz="2400" dirty="0"/>
+          </a:p>
+        </p:txBody>
+      </p:sp>
+      <p:sp>
+        <p:nvSpPr>
+          <p:cNvPr id="5" name="Answer 1"/>
+          <p:cNvSpPr txBox="1"/>
+          <p:nvPr/>
+        </p:nvSpPr>
+        <p:spPr>
+          <a:xfrm>
+            <a:off x="1325880" y="1417320"/>
+            <a:ext cx="6035040" cy="1097280"/>
+          </a:xfrm>
+          <a:prstGeom prst="rect">
+            <a:avLst/>
+          </a:prstGeom>
+          <a:noFill/>
+          <a:ln/>
+        </p:spPr>
+        <p:txBody>
+          <a:bodyPr wrap="square" lIns="0" tIns="0" rIns="0" bIns="0" rtlCol="0" anchor="t"/>
+          <a:lstStyle/>
+          <a:p>
+            <a:pPr indent="0" marL="0">
+              <a:buNone/>
+            </a:pPr>
+            <a:r>
+              <a:rPr lang="en-US" sz="2400" b="1" dirty="0">
+                <a:solidFill>
+                  <a:schemeClr val="bg1"/>
+                </a:solidFill>
+              </a:rPr>
+              <a:t>Real problem</a:t>
+            </a:r>
+            <a:endParaRPr lang="en-US" sz="1600" dirty="0"/>
+          </a:p>
+          <a:p>
+            <a:pPr indent="0" marL="0">
+              <a:buNone/>
+            </a:pPr>
+            <a:r>
+              <a:rPr lang="en-US" sz="1600" dirty="0">
+                <a:solidFill>
+                  <a:schemeClr val="bg2"/>
+                </a:solidFill>
+              </a:rPr>
+              <a:t>Blind job seekers lose hours on every search</a:t>
+            </a:r>
+            <a:endParaRPr lang="en-US" sz="1600" dirty="0"/>
+          </a:p>
+        </p:txBody>
+      </p:sp>
+      <p:sp>
+        <p:nvSpPr>
+          <p:cNvPr id="6" name="Answer 2 check"/>
+          <p:cNvSpPr/>
+          <p:nvPr/>
+        </p:nvSpPr>
+        <p:spPr>
+          <a:xfrm>
+            <a:off x="548640" y="2834640"/>
+            <a:ext cx="548640" cy="548640"/>
+          </a:xfrm>
+          <a:prstGeom prst="ellipse">
+            <a:avLst/>
+          </a:prstGeom>
+          <a:solidFill>
+            <a:srgbClr val="10B981"/>
+          </a:solidFill>
+          <a:ln/>
+        </p:spPr>
+      </p:sp>
+      <p:sp>
+        <p:nvSpPr>
+          <p:cNvPr id="7" name="Answer 2 tick"/>
+          <p:cNvSpPr txBox="1"/>
+          <p:nvPr/>
+        </p:nvSpPr>
+        <p:spPr>
+          <a:xfrm>
+            <a:off x="548640" y="2834640"/>
+            <a:ext cx="548640" cy="548640"/>
+          </a:xfrm>
+          <a:prstGeom prst="rect">
+            <a:avLst/>
+          </a:prstGeom>
+          <a:noFill/>
+          <a:ln/>
+        </p:spPr>
+        <p:txBody>
+          <a:bodyPr wrap="square" lIns="0" tIns="0" rIns="0" bIns="0" rtlCol="0" anchor="ctr"/>
+          <a:lstStyle/>
+          <a:p>
+            <a:pPr algn="ctr" indent="0" marL="0">
+              <a:buNone/>
+            </a:pPr>
+            <a:r>
+              <a:rPr lang="en-US" sz="2400" b="1" dirty="0">
+                <a:solidFill>
+                  <a:schemeClr val="bg1"/>
+                </a:solidFill>
+              </a:rPr>
+              <a:t>✓</a:t>
+            </a:r>
+            <a:endParaRPr lang="en-US" sz="2400" dirty="0"/>
+          </a:p>
+        </p:txBody>
+      </p:sp>
+      <p:sp>
+        <p:nvSpPr>
+          <p:cNvPr id="8" name="Answer 2"/>
+          <p:cNvSpPr txBox="1"/>
+          <p:nvPr/>
+        </p:nvSpPr>
+        <p:spPr>
+          <a:xfrm>
+            <a:off x="1325880" y="2788920"/>
+            <a:ext cx="6035040" cy="1097280"/>
+          </a:xfrm>
+          <a:prstGeom prst="rect">
+            <a:avLst/>
+          </a:prstGeom>
+          <a:noFill/>
+          <a:ln/>
+        </p:spPr>
+        <p:txBody>
+          <a:bodyPr wrap="square" lIns="0" tIns="0" rIns="0" bIns="0" rtlCol="0" anchor="t"/>
+          <a:lstStyle/>
+          <a:p>
+            <a:pPr indent="0" marL="0">
+              <a:buNone/>
+            </a:pPr>
+            <a:r>
+              <a:rPr lang="en-US" sz="2400" b="1" dirty="0">
+                <a:solidFill>
+                  <a:schemeClr val="bg1"/>
+                </a:solidFill>
+              </a:rPr>
+              <a:t>WorkBuddy is the engine</a:t>
+            </a:r>
+            <a:endParaRPr lang="en-US" sz="1600" dirty="0"/>
+          </a:p>
+          <a:p>
+            <a:pPr indent="0" marL="0">
+              <a:buNone/>
+            </a:pPr>
+            <a:r>
+              <a:rPr lang="en-US" sz="1600" dirty="0">
+                <a:solidFill>
+                  <a:schemeClr val="bg2"/>
+                </a:solidFill>
+              </a:rPr>
+              <a:t>Its files, web search and email drive our MCP tools</a:t>
+            </a:r>
+            <a:endParaRPr lang="en-US" sz="1600" dirty="0"/>
+          </a:p>
+        </p:txBody>
+      </p:sp>
+      <p:sp>
+        <p:nvSpPr>
+          <p:cNvPr id="9" name="Answer 3 check"/>
+          <p:cNvSpPr/>
+          <p:nvPr/>
+        </p:nvSpPr>
+        <p:spPr>
+          <a:xfrm>
+            <a:off x="548640" y="4206240"/>
+            <a:ext cx="548640" cy="548640"/>
+          </a:xfrm>
+          <a:prstGeom prst="ellipse">
+            <a:avLst/>
+          </a:prstGeom>
+          <a:solidFill>
+            <a:srgbClr val="10B981"/>
+          </a:solidFill>
+          <a:ln/>
+        </p:spPr>
+      </p:sp>
+      <p:sp>
+        <p:nvSpPr>
+          <p:cNvPr id="10" name="Answer 3 tick"/>
+          <p:cNvSpPr txBox="1"/>
+          <p:nvPr/>
+        </p:nvSpPr>
+        <p:spPr>
+          <a:xfrm>
+            <a:off x="548640" y="4206240"/>
+            <a:ext cx="548640" cy="548640"/>
+          </a:xfrm>
+          <a:prstGeom prst="rect">
+            <a:avLst/>
+          </a:prstGeom>
+          <a:noFill/>
+          <a:ln/>
+        </p:spPr>
+        <p:txBody>
+          <a:bodyPr wrap="square" lIns="0" tIns="0" rIns="0" bIns="0" rtlCol="0" anchor="ctr"/>
+          <a:lstStyle/>
+          <a:p>
+            <a:pPr algn="ctr" indent="0" marL="0">
+              <a:buNone/>
+            </a:pPr>
+            <a:r>
+              <a:rPr lang="en-US" sz="2400" b="1" dirty="0">
+                <a:solidFill>
+                  <a:schemeClr val="bg1"/>
+                </a:solidFill>
+              </a:rPr>
+              <a:t>✓</a:t>
+            </a:r>
+            <a:endParaRPr lang="en-US" sz="2400" dirty="0"/>
+          </a:p>
+        </p:txBody>
+      </p:sp>
+      <p:sp>
+        <p:nvSpPr>
+          <p:cNvPr id="11" name="Answer 3"/>
+          <p:cNvSpPr txBox="1"/>
+          <p:nvPr/>
+        </p:nvSpPr>
+        <p:spPr>
+          <a:xfrm>
+            <a:off x="1325880" y="4160520"/>
+            <a:ext cx="6035040" cy="1097280"/>
+          </a:xfrm>
+          <a:prstGeom prst="rect">
+            <a:avLst/>
+          </a:prstGeom>
+          <a:noFill/>
+          <a:ln/>
+        </p:spPr>
+        <p:txBody>
+          <a:bodyPr wrap="square" lIns="0" tIns="0" rIns="0" bIns="0" rtlCol="0" anchor="t"/>
+          <a:lstStyle/>
+          <a:p>
+            <a:pPr indent="0" marL="0">
+              <a:buNone/>
+            </a:pPr>
+            <a:r>
+              <a:rPr lang="en-US" sz="2400" b="1" dirty="0">
+                <a:solidFill>
+                  <a:schemeClr val="bg1"/>
+                </a:solidFill>
+              </a:rPr>
+              <a:t>Gets it done</a:t>
+            </a:r>
+            <a:endParaRPr lang="en-US" sz="1600" dirty="0"/>
+          </a:p>
+          <a:p>
+            <a:pPr indent="0" marL="0">
+              <a:buNone/>
+            </a:pPr>
+            <a:r>
+              <a:rPr lang="en-US" sz="1600" dirty="0">
+                <a:solidFill>
+                  <a:schemeClr val="bg2"/>
+                </a:solidFill>
+              </a:rPr>
+              <a:t>Checked, verified, applied only with her OK</a:t>
+            </a:r>
+            <a:endParaRPr lang="en-US" sz="1600" dirty="0"/>
+          </a:p>
+        </p:txBody>
       </p:sp>
       <p:pic>
         <p:nvPicPr>
-          <p:cNvPr id="4" name="QR 1" descr="QR code for hirebuddy-k543.onrender.com">    </p:cNvPr>
+          <p:cNvPr id="12" name="QR 1" descr="QR code for hirebuddy-k543.onrender.com">    </p:cNvPr>
           <p:cNvPicPr>
             <a:picLocks noChangeAspect="1"/>
           </p:cNvPicPr>
@@ -4492,8 +4788,8 @@
         </p:blipFill>
         <p:spPr>
           <a:xfrm>
-            <a:off x="2468880" y="1554480"/>
-            <a:ext cx="2468880" cy="2468880"/>
+            <a:off x="7818120" y="1920240"/>
+            <a:ext cx="1783080" cy="1783080"/>
           </a:xfrm>
           <a:prstGeom prst="rect">
             <a:avLst/>
@@ -4502,14 +4798,14 @@
       </p:pic>
       <p:sp>
         <p:nvSpPr>
-          <p:cNvPr id="5" name="QR 1 heading"/>
+          <p:cNvPr id="13" name="QR 1 heading"/>
           <p:cNvSpPr txBox="1"/>
           <p:nvPr/>
         </p:nvSpPr>
         <p:spPr>
           <a:xfrm>
-            <a:off x="1920240" y="4206240"/>
-            <a:ext cx="3566160" cy="411480"/>
+            <a:off x="7726680" y="3794760"/>
+            <a:ext cx="1965960" cy="365760"/>
           </a:xfrm>
           <a:prstGeom prst="rect">
             <a:avLst/>
@@ -4525,43 +4821,7 @@
               <a:buNone/>
             </a:pPr>
             <a:r>
-              <a:rPr lang="en-US" sz="1800" b="1" dirty="0">
-                <a:solidFill>
-                  <a:schemeClr val="bg1"/>
-                </a:solidFill>
-              </a:rPr>
-              <a:t>Live app</a:t>
-            </a:r>
-            <a:endParaRPr lang="en-US" sz="1800" dirty="0"/>
-          </a:p>
-        </p:txBody>
-      </p:sp>
-      <p:sp>
-        <p:nvSpPr>
-          <p:cNvPr id="6" name="QR 1 link"/>
-          <p:cNvSpPr txBox="1"/>
-          <p:nvPr/>
-        </p:nvSpPr>
-        <p:spPr>
-          <a:xfrm>
-            <a:off x="1920240" y="4663440"/>
-            <a:ext cx="3566160" cy="365760"/>
-          </a:xfrm>
-          <a:prstGeom prst="rect">
-            <a:avLst/>
-          </a:prstGeom>
-          <a:noFill/>
-          <a:ln/>
-        </p:spPr>
-        <p:txBody>
-          <a:bodyPr wrap="square" lIns="0" tIns="0" rIns="0" bIns="0" rtlCol="0" anchor="ctr"/>
-          <a:lstStyle/>
-          <a:p>
-            <a:pPr algn="ctr" indent="0" marL="0">
-              <a:buNone/>
-            </a:pPr>
-            <a:r>
-              <a:rPr lang="en-US" sz="1400" u="sng" dirty="0">
+              <a:rPr lang="en-US" sz="1400" b="1" u="sng" dirty="0">
                 <a:solidFill>
                   <a:schemeClr val="accent1"/>
                 </a:solidFill>
@@ -4573,37 +4833,15 @@
                   </a:extLst>
                 </a:hlinkClick>
               </a:rPr>
-              <a:t>hirebuddy-k543.onrender.com</a:t>
+              <a:t>Live app</a:t>
             </a:r>
             <a:endParaRPr lang="en-US" sz="1400" dirty="0"/>
           </a:p>
         </p:txBody>
-      </p:sp>
-      <p:sp>
-        <p:nvSpPr>
-          <p:cNvPr id="7" name="QR card 2"/>
-          <p:cNvSpPr/>
-          <p:nvPr/>
-        </p:nvSpPr>
-        <p:spPr>
-          <a:xfrm>
-            <a:off x="6492240" y="1280160"/>
-            <a:ext cx="3931920" cy="4023360"/>
-          </a:xfrm>
-          <a:prstGeom prst="roundRect">
-            <a:avLst>
-              <a:gd name="adj" fmla="val 2326"/>
-            </a:avLst>
-          </a:prstGeom>
-          <a:solidFill>
-            <a:srgbClr val="1E293B"/>
-          </a:solidFill>
-          <a:ln/>
-        </p:spPr>
       </p:sp>
       <p:pic>
         <p:nvPicPr>
-          <p:cNvPr id="8" name="QR 2" descr="QR code for github.com/Josan88/job-buddy">    </p:cNvPr>
+          <p:cNvPr id="14" name="QR 2" descr="QR code for github.com/Josan88/job-buddy">    </p:cNvPr>
           <p:cNvPicPr>
             <a:picLocks noChangeAspect="1"/>
           </p:cNvPicPr>
@@ -4617,8 +4855,8 @@
         </p:blipFill>
         <p:spPr>
           <a:xfrm>
-            <a:off x="7223760" y="1554480"/>
-            <a:ext cx="2468880" cy="2468880"/>
+            <a:off x="9829800" y="1920240"/>
+            <a:ext cx="1783080" cy="1783080"/>
           </a:xfrm>
           <a:prstGeom prst="rect">
             <a:avLst/>
@@ -4627,14 +4865,14 @@
       </p:pic>
       <p:sp>
         <p:nvSpPr>
-          <p:cNvPr id="9" name="QR 2 heading"/>
+          <p:cNvPr id="15" name="QR 2 heading"/>
           <p:cNvSpPr txBox="1"/>
           <p:nvPr/>
         </p:nvSpPr>
         <p:spPr>
           <a:xfrm>
-            <a:off x="6675120" y="4206240"/>
-            <a:ext cx="3566160" cy="411480"/>
+            <a:off x="9738360" y="3794760"/>
+            <a:ext cx="1965960" cy="365760"/>
           </a:xfrm>
           <a:prstGeom prst="rect">
             <a:avLst/>
@@ -4650,43 +4888,7 @@
               <a:buNone/>
             </a:pPr>
             <a:r>
-              <a:rPr lang="en-US" sz="1800" b="1" dirty="0">
-                <a:solidFill>
-                  <a:schemeClr val="bg1"/>
-                </a:solidFill>
-              </a:rPr>
-              <a:t>Code + WorkBuddy setup</a:t>
-            </a:r>
-            <a:endParaRPr lang="en-US" sz="1800" dirty="0"/>
-          </a:p>
-        </p:txBody>
-      </p:sp>
-      <p:sp>
-        <p:nvSpPr>
-          <p:cNvPr id="10" name="QR 2 link"/>
-          <p:cNvSpPr txBox="1"/>
-          <p:nvPr/>
-        </p:nvSpPr>
-        <p:spPr>
-          <a:xfrm>
-            <a:off x="6675120" y="4663440"/>
-            <a:ext cx="3566160" cy="365760"/>
-          </a:xfrm>
-          <a:prstGeom prst="rect">
-            <a:avLst/>
-          </a:prstGeom>
-          <a:noFill/>
-          <a:ln/>
-        </p:spPr>
-        <p:txBody>
-          <a:bodyPr wrap="square" lIns="0" tIns="0" rIns="0" bIns="0" rtlCol="0" anchor="ctr"/>
-          <a:lstStyle/>
-          <a:p>
-            <a:pPr algn="ctr" indent="0" marL="0">
-              <a:buNone/>
-            </a:pPr>
-            <a:r>
-              <a:rPr lang="en-US" sz="1400" u="sng" dirty="0">
+              <a:rPr lang="en-US" sz="1400" b="1" u="sng" dirty="0">
                 <a:solidFill>
                   <a:schemeClr val="accent1"/>
                 </a:solidFill>
@@ -4698,7 +4900,7 @@
                   </a:extLst>
                 </a:hlinkClick>
               </a:rPr>
-              <a:t>github.com/Josan88/job-buddy</a:t>
+              <a:t>Code + setup</a:t>
             </a:r>
             <a:endParaRPr lang="en-US" sz="1400" dirty="0"/>
           </a:p>
@@ -4706,14 +4908,14 @@
       </p:sp>
       <p:sp>
         <p:nvSpPr>
-          <p:cNvPr id="11" name="Hint"/>
+          <p:cNvPr id="16" name="Tagline"/>
           <p:cNvSpPr txBox="1"/>
           <p:nvPr/>
         </p:nvSpPr>
         <p:spPr>
           <a:xfrm>
-            <a:off x="548640" y="5532120"/>
-            <a:ext cx="11064240" cy="365760"/>
+            <a:off x="548640" y="5577840"/>
+            <a:ext cx="11064240" cy="457200"/>
           </a:xfrm>
           <a:prstGeom prst="rect">
             <a:avLst/>
@@ -4725,18 +4927,18 @@
           <a:bodyPr wrap="square" lIns="0" tIns="0" rIns="0" bIns="0" rtlCol="0" anchor="ctr"/>
           <a:lstStyle/>
           <a:p>
-            <a:pPr algn="ctr" indent="0" marL="0">
-              <a:buNone/>
-            </a:pPr>
-            <a:r>
-              <a:rPr lang="en-US" sz="1400" dirty="0">
-                <a:solidFill>
-                  <a:schemeClr val="bg2"/>
-                </a:solidFill>
-              </a:rPr>
-              <a:t>Paste Nadia's sentence, or write your own.</a:t>
-            </a:r>
-            <a:endParaRPr lang="en-US" sz="1400" dirty="0"/>
+            <a:pPr indent="0" marL="0">
+              <a:buNone/>
+            </a:pPr>
+            <a:r>
+              <a:rPr lang="en-US" sz="2200" b="1" dirty="0">
+                <a:solidFill>
+                  <a:schemeClr val="accent1"/>
+                </a:solidFill>
+              </a:rPr>
+              <a:t>HireBuddy: work that gets done.</a:t>
+            </a:r>
+            <a:endParaRPr lang="en-US" sz="2200" dirty="0"/>
           </a:p>
         </p:txBody>
       </p:sp>

</xml_diff>